<commit_message>
Lesson sd-10-018: explain the six load balancing algorithms from the nginx and HAProxy documentation instead of following the source sentences, with the figure, metadata and deck
Co-Authored-By: Claude Sonnet 5.5 <noreply@anthropic.com>
Claude-Session: https://claude.ai/code/session_011dmt3ZFdN8sjiTfDnyUVN7
</commit_message>
<xml_diff>
--- a/system-design-101/vi/lessons/sd-10-018/slides/sd-10-018.pptx
+++ b/system-design-101/vi/lessons/sd-10-018/slides/sd-10-018.pptx
@@ -4877,15 +4877,15 @@
               <a:buChar char="•"/>
             </a:pPr>
             <a:r>
-              <a:rPr lang="en-US" sz="2550" dirty="0" spc="-5" kern="0">
-                <a:solidFill>
-                  <a:srgbClr val="14161C"/>
-                </a:solidFill>
-                <a:latin typeface="Be Vietnam Pro" pitchFamily="34" charset="0"/>
-                <a:ea typeface="Be Vietnam Pro" pitchFamily="34" charset="-122"/>
-                <a:cs typeface="Be Vietnam Pro" pitchFamily="34" charset="-120"/>
-              </a:rPr>
-              <a:t>Đọc</a:t>
+              <a:rPr lang="en-US" sz="2550" dirty="0" spc="1" kern="0">
+                <a:solidFill>
+                  <a:srgbClr val="14161C"/>
+                </a:solidFill>
+                <a:latin typeface="Be Vietnam Pro" pitchFamily="34" charset="0"/>
+                <a:ea typeface="Be Vietnam Pro" pitchFamily="34" charset="-122"/>
+                <a:cs typeface="Be Vietnam Pro" pitchFamily="34" charset="-120"/>
+              </a:rPr>
+              <a:t>Hiểu</a:t>
             </a:r>
             <a:r>
               <a:rPr lang="en-US" sz="2550" dirty="0" spc="20" kern="0">
@@ -4899,39 +4899,6 @@
               <a:t> từng</a:t>
             </a:r>
             <a:r>
-              <a:rPr lang="en-US" sz="2550" dirty="0" spc="-6" kern="0">
-                <a:solidFill>
-                  <a:srgbClr val="14161C"/>
-                </a:solidFill>
-                <a:latin typeface="Be Vietnam Pro" pitchFamily="34" charset="0"/>
-                <a:ea typeface="Be Vietnam Pro" pitchFamily="34" charset="-122"/>
-                <a:cs typeface="Be Vietnam Pro" pitchFamily="34" charset="-120"/>
-              </a:rPr>
-              <a:t> thuật</a:t>
-            </a:r>
-            <a:r>
-              <a:rPr lang="en-US" sz="2550" dirty="0" spc="-12" kern="0">
-                <a:solidFill>
-                  <a:srgbClr val="14161C"/>
-                </a:solidFill>
-                <a:latin typeface="Be Vietnam Pro" pitchFamily="34" charset="0"/>
-                <a:ea typeface="Be Vietnam Pro" pitchFamily="34" charset="-122"/>
-                <a:cs typeface="Be Vietnam Pro" pitchFamily="34" charset="-120"/>
-              </a:rPr>
-              <a:t> toán</a:t>
-            </a:r>
-            <a:r>
-              <a:rPr lang="en-US" sz="2550" dirty="0" spc="-2" kern="0">
-                <a:solidFill>
-                  <a:srgbClr val="14161C"/>
-                </a:solidFill>
-                <a:latin typeface="Be Vietnam Pro" pitchFamily="34" charset="0"/>
-                <a:ea typeface="Be Vietnam Pro" pitchFamily="34" charset="-122"/>
-                <a:cs typeface="Be Vietnam Pro" pitchFamily="34" charset="-120"/>
-              </a:rPr>
-              <a:t> theo</a:t>
-            </a:r>
-            <a:r>
               <a:rPr lang="en-US" sz="2550" dirty="0" spc="0" kern="0">
                 <a:solidFill>
                   <a:srgbClr val="14161C"/>
@@ -4940,7 +4907,51 @@
                 <a:ea typeface="Be Vietnam Pro" pitchFamily="34" charset="-122"/>
                 <a:cs typeface="Be Vietnam Pro" pitchFamily="34" charset="-120"/>
               </a:rPr>
-              <a:t> lời nguồn</a:t>
+              <a:t> cách</a:t>
+            </a:r>
+            <a:r>
+              <a:rPr lang="en-US" sz="2550" dirty="0" spc="1" kern="0">
+                <a:solidFill>
+                  <a:srgbClr val="14161C"/>
+                </a:solidFill>
+                <a:latin typeface="Be Vietnam Pro" pitchFamily="34" charset="0"/>
+                <a:ea typeface="Be Vietnam Pro" pitchFamily="34" charset="-122"/>
+                <a:cs typeface="Be Vietnam Pro" pitchFamily="34" charset="-120"/>
+              </a:rPr>
+              <a:t> qua</a:t>
+            </a:r>
+            <a:r>
+              <a:rPr lang="en-US" sz="2550" dirty="0" spc="0" kern="0">
+                <a:solidFill>
+                  <a:srgbClr val="14161C"/>
+                </a:solidFill>
+                <a:latin typeface="Be Vietnam Pro" pitchFamily="34" charset="0"/>
+                <a:ea typeface="Be Vietnam Pro" pitchFamily="34" charset="-122"/>
+                <a:cs typeface="Be Vietnam Pro" pitchFamily="34" charset="-120"/>
+              </a:rPr>
+              <a:t> nginx</a:t>
+            </a:r>
+            <a:r>
+              <a:rPr lang="en-US" sz="2550" dirty="0" spc="-19" kern="0">
+                <a:solidFill>
+                  <a:srgbClr val="14161C"/>
+                </a:solidFill>
+                <a:latin typeface="Be Vietnam Pro" pitchFamily="34" charset="0"/>
+                <a:ea typeface="Be Vietnam Pro" pitchFamily="34" charset="-122"/>
+                <a:cs typeface="Be Vietnam Pro" pitchFamily="34" charset="-120"/>
+              </a:rPr>
+              <a:t> và</a:t>
+            </a:r>
+            <a:r>
+              <a:rPr lang="en-US" sz="2550" dirty="0" spc="-22" kern="0">
+                <a:solidFill>
+                  <a:srgbClr val="14161C"/>
+                </a:solidFill>
+                <a:latin typeface="Be Vietnam Pro" pitchFamily="34" charset="0"/>
+                <a:ea typeface="Be Vietnam Pro" pitchFamily="34" charset="-122"/>
+                <a:cs typeface="Be Vietnam Pro" pitchFamily="34" charset="-120"/>
+              </a:rPr>
+              <a:t> HAProxy</a:t>
             </a:r>
             <a:endParaRPr lang="en-US" sz="2550" dirty="0"/>
           </a:p>
@@ -4979,6 +4990,17 @@
               <a:t> biệt</a:t>
             </a:r>
             <a:r>
+              <a:rPr lang="en-US" sz="2550" dirty="0" spc="-1" kern="0">
+                <a:solidFill>
+                  <a:srgbClr val="14161C"/>
+                </a:solidFill>
+                <a:latin typeface="Be Vietnam Pro" pitchFamily="34" charset="0"/>
+                <a:ea typeface="Be Vietnam Pro" pitchFamily="34" charset="-122"/>
+                <a:cs typeface="Be Vietnam Pro" pitchFamily="34" charset="-120"/>
+              </a:rPr>
+              <a:t> hai</a:t>
+            </a:r>
+            <a:r>
               <a:rPr lang="en-US" sz="2550" dirty="0" spc="0" kern="0">
                 <a:solidFill>
                   <a:srgbClr val="14161C"/>
@@ -4987,29 +5009,18 @@
                 <a:ea typeface="Be Vietnam Pro" pitchFamily="34" charset="-122"/>
                 <a:cs typeface="Be Vietnam Pro" pitchFamily="34" charset="-120"/>
               </a:rPr>
-              <a:t> nhóm</a:t>
-            </a:r>
-            <a:r>
-              <a:rPr lang="en-US" sz="2550" dirty="0" spc="1" kern="0">
-                <a:solidFill>
-                  <a:srgbClr val="14161C"/>
-                </a:solidFill>
-                <a:latin typeface="Be Vietnam Pro" pitchFamily="34" charset="0"/>
-                <a:ea typeface="Be Vietnam Pro" pitchFamily="34" charset="-122"/>
-                <a:cs typeface="Be Vietnam Pro" pitchFamily="34" charset="-120"/>
-              </a:rPr>
-              <a:t> tĩnh</a:t>
-            </a:r>
-            <a:r>
-              <a:rPr lang="en-US" sz="2550" dirty="0" spc="-19" kern="0">
-                <a:solidFill>
-                  <a:srgbClr val="14161C"/>
-                </a:solidFill>
-                <a:latin typeface="Be Vietnam Pro" pitchFamily="34" charset="0"/>
-                <a:ea typeface="Be Vietnam Pro" pitchFamily="34" charset="-122"/>
-                <a:cs typeface="Be Vietnam Pro" pitchFamily="34" charset="-120"/>
-              </a:rPr>
-              <a:t> và</a:t>
+              <a:t> nghĩa</a:t>
+            </a:r>
+            <a:r>
+              <a:rPr lang="en-US" sz="2550" dirty="0" spc="-1" kern="0">
+                <a:solidFill>
+                  <a:srgbClr val="14161C"/>
+                </a:solidFill>
+                <a:latin typeface="Be Vietnam Pro" pitchFamily="34" charset="0"/>
+                <a:ea typeface="Be Vietnam Pro" pitchFamily="34" charset="-122"/>
+                <a:cs typeface="Be Vietnam Pro" pitchFamily="34" charset="-120"/>
+              </a:rPr>
+              <a:t> của</a:t>
             </a:r>
             <a:r>
               <a:rPr lang="en-US" sz="2550" dirty="0" spc="0" kern="0">
@@ -5020,10 +5031,10 @@
                 <a:ea typeface="Be Vietnam Pro" pitchFamily="34" charset="-122"/>
                 <a:cs typeface="Be Vietnam Pro" pitchFamily="34" charset="-120"/>
               </a:rPr>
-              <a:t> nhóm</a:t>
-            </a:r>
-            <a:r>
-              <a:rPr lang="en-US" sz="2550" dirty="0" spc="10" kern="0">
+              <a:t> tĩnh,</a:t>
+            </a:r>
+            <a:r>
+              <a:rPr lang="en-US" sz="2550" dirty="0" spc="11" kern="0">
                 <a:solidFill>
                   <a:srgbClr val="14161C"/>
                 </a:solidFill>
@@ -5045,6 +5056,39 @@
               <a:buChar char="•"/>
             </a:pPr>
             <a:r>
+              <a:rPr lang="en-US" sz="2550" dirty="0" spc="-11" kern="0">
+                <a:solidFill>
+                  <a:srgbClr val="14161C"/>
+                </a:solidFill>
+                <a:latin typeface="Be Vietnam Pro" pitchFamily="34" charset="0"/>
+                <a:ea typeface="Be Vietnam Pro" pitchFamily="34" charset="-122"/>
+                <a:cs typeface="Be Vietnam Pro" pitchFamily="34" charset="-120"/>
+              </a:rPr>
+              <a:t>Thấy</a:t>
+            </a:r>
+            <a:r>
+              <a:rPr lang="en-US" sz="2550" dirty="0" spc="-1" kern="0">
+                <a:solidFill>
+                  <a:srgbClr val="14161C"/>
+                </a:solidFill>
+                <a:latin typeface="Be Vietnam Pro" pitchFamily="34" charset="0"/>
+                <a:ea typeface="Be Vietnam Pro" pitchFamily="34" charset="-122"/>
+                <a:cs typeface="Be Vietnam Pro" pitchFamily="34" charset="-120"/>
+              </a:rPr>
+              <a:t> hash</a:t>
+            </a:r>
+            <a:r>
+              <a:rPr lang="en-US" sz="2550" dirty="0" spc="12" kern="0">
+                <a:solidFill>
+                  <a:srgbClr val="14161C"/>
+                </a:solidFill>
+                <a:latin typeface="Be Vietnam Pro" pitchFamily="34" charset="0"/>
+                <a:ea typeface="Be Vietnam Pro" pitchFamily="34" charset="-122"/>
+                <a:cs typeface="Be Vietnam Pro" pitchFamily="34" charset="-120"/>
+              </a:rPr>
+              <a:t> đổi</a:t>
+            </a:r>
+            <a:r>
               <a:rPr lang="en-US" sz="2550" dirty="0" spc="0" kern="0">
                 <a:solidFill>
                   <a:srgbClr val="14161C"/>
@@ -5053,62 +5097,40 @@
                 <a:ea typeface="Be Vietnam Pro" pitchFamily="34" charset="-122"/>
                 <a:cs typeface="Be Vietnam Pro" pitchFamily="34" charset="-120"/>
               </a:rPr>
-              <a:t>Gặp lại</a:t>
-            </a:r>
-            <a:r>
-              <a:rPr lang="en-US" sz="2550" dirty="0" spc="1" kern="0">
-                <a:solidFill>
-                  <a:srgbClr val="14161C"/>
-                </a:solidFill>
-                <a:latin typeface="Be Vietnam Pro" pitchFamily="34" charset="0"/>
-                <a:ea typeface="Be Vietnam Pro" pitchFamily="34" charset="-122"/>
-                <a:cs typeface="Be Vietnam Pro" pitchFamily="34" charset="-120"/>
-              </a:rPr>
-              <a:t> các</a:t>
-            </a:r>
-            <a:r>
-              <a:rPr lang="en-US" sz="2550" dirty="0" spc="-12" kern="0">
-                <a:solidFill>
-                  <a:srgbClr val="14161C"/>
-                </a:solidFill>
-                <a:latin typeface="Be Vietnam Pro" pitchFamily="34" charset="0"/>
-                <a:ea typeface="Be Vietnam Pro" pitchFamily="34" charset="-122"/>
-                <a:cs typeface="Be Vietnam Pro" pitchFamily="34" charset="-120"/>
-              </a:rPr>
-              <a:t> tên</a:t>
-            </a:r>
-            <a:r>
-              <a:rPr lang="en-US" sz="2550" dirty="0" spc="17" kern="0">
-                <a:solidFill>
-                  <a:srgbClr val="14161C"/>
-                </a:solidFill>
-                <a:latin typeface="Be Vietnam Pro" pitchFamily="34" charset="0"/>
-                <a:ea typeface="Be Vietnam Pro" pitchFamily="34" charset="-122"/>
-                <a:cs typeface="Be Vietnam Pro" pitchFamily="34" charset="-120"/>
-              </a:rPr>
-              <a:t> đó</a:t>
-            </a:r>
-            <a:r>
-              <a:rPr lang="en-US" sz="2550" dirty="0" spc="-17" kern="0">
-                <a:solidFill>
-                  <a:srgbClr val="14161C"/>
-                </a:solidFill>
-                <a:latin typeface="Be Vietnam Pro" pitchFamily="34" charset="0"/>
-                <a:ea typeface="Be Vietnam Pro" pitchFamily="34" charset="-122"/>
-                <a:cs typeface="Be Vietnam Pro" pitchFamily="34" charset="-120"/>
-              </a:rPr>
-              <a:t> trong</a:t>
-            </a:r>
-            <a:r>
-              <a:rPr lang="en-US" sz="2550" dirty="0" spc="0" kern="0">
-                <a:solidFill>
-                  <a:srgbClr val="14161C"/>
-                </a:solidFill>
-                <a:latin typeface="Be Vietnam Pro" pitchFamily="34" charset="0"/>
-                <a:ea typeface="Be Vietnam Pro" pitchFamily="34" charset="-122"/>
-                <a:cs typeface="Be Vietnam Pro" pitchFamily="34" charset="-120"/>
-              </a:rPr>
-              <a:t> nginx</a:t>
+              <a:t> khi</a:t>
+            </a:r>
+            <a:r>
+              <a:rPr lang="en-US" sz="2550" dirty="0" spc="-11" kern="0">
+                <a:solidFill>
+                  <a:srgbClr val="14161C"/>
+                </a:solidFill>
+                <a:latin typeface="Be Vietnam Pro" pitchFamily="34" charset="0"/>
+                <a:ea typeface="Be Vietnam Pro" pitchFamily="34" charset="-122"/>
+                <a:cs typeface="Be Vietnam Pro" pitchFamily="34" charset="-120"/>
+              </a:rPr>
+              <a:t> số</a:t>
+            </a:r>
+            <a:r>
+              <a:rPr lang="en-US" sz="2550" dirty="0" spc="-9" kern="0">
+                <a:solidFill>
+                  <a:srgbClr val="14161C"/>
+                </a:solidFill>
+                <a:latin typeface="Be Vietnam Pro" pitchFamily="34" charset="0"/>
+                <a:ea typeface="Be Vietnam Pro" pitchFamily="34" charset="-122"/>
+                <a:cs typeface="Be Vietnam Pro" pitchFamily="34" charset="-120"/>
+              </a:rPr>
+              <a:t> máy</a:t>
+            </a:r>
+            <a:r>
+              <a:rPr lang="en-US" sz="2550" dirty="0" spc="13" kern="0">
+                <a:solidFill>
+                  <a:srgbClr val="14161C"/>
+                </a:solidFill>
+                <a:latin typeface="Be Vietnam Pro" pitchFamily="34" charset="0"/>
+                <a:ea typeface="Be Vietnam Pro" pitchFamily="34" charset="-122"/>
+                <a:cs typeface="Be Vietnam Pro" pitchFamily="34" charset="-120"/>
+              </a:rPr>
+              <a:t> đổi</a:t>
             </a:r>
             <a:endParaRPr lang="en-US" sz="2550" dirty="0"/>
           </a:p>
@@ -5929,95 +5951,62 @@
                 <a:ea typeface="Be Vietnam Pro" pitchFamily="34" charset="-122"/>
                 <a:cs typeface="Be Vietnam Pro" pitchFamily="34" charset="-120"/>
               </a:rPr>
-              <a:t>Sticky:</a:t>
-            </a:r>
-            <a:r>
-              <a:rPr lang="en-US" sz="2550" dirty="0" spc="1" kern="0">
-                <a:solidFill>
-                  <a:srgbClr val="F3EEE3"/>
-                </a:solidFill>
-                <a:latin typeface="Be Vietnam Pro" pitchFamily="34" charset="0"/>
-                <a:ea typeface="Be Vietnam Pro" pitchFamily="34" charset="-122"/>
-                <a:cs typeface="Be Vietnam Pro" pitchFamily="34" charset="-120"/>
-              </a:rPr>
-              <a:t> Alice</a:t>
-            </a:r>
-            <a:r>
-              <a:rPr lang="en-US" sz="2550" dirty="0" spc="-13" kern="0">
-                <a:solidFill>
-                  <a:srgbClr val="F3EEE3"/>
-                </a:solidFill>
-                <a:latin typeface="Be Vietnam Pro" pitchFamily="34" charset="0"/>
-                <a:ea typeface="Be Vietnam Pro" pitchFamily="34" charset="-122"/>
-                <a:cs typeface="Be Vietnam Pro" pitchFamily="34" charset="-120"/>
-              </a:rPr>
-              <a:t> tới</a:t>
-            </a:r>
-            <a:r>
-              <a:rPr lang="en-US" sz="2550" dirty="0" spc="1" kern="0">
-                <a:solidFill>
-                  <a:srgbClr val="F3EEE3"/>
-                </a:solidFill>
-                <a:latin typeface="Be Vietnam Pro" pitchFamily="34" charset="0"/>
-                <a:ea typeface="Be Vietnam Pro" pitchFamily="34" charset="-122"/>
-                <a:cs typeface="Be Vietnam Pro" pitchFamily="34" charset="-120"/>
-              </a:rPr>
-              <a:t> A</a:t>
-            </a:r>
-            <a:r>
-              <a:rPr lang="en-US" sz="2550" dirty="0" spc="2" kern="0">
-                <a:solidFill>
-                  <a:srgbClr val="F3EEE3"/>
-                </a:solidFill>
-                <a:latin typeface="Be Vietnam Pro" pitchFamily="34" charset="0"/>
-                <a:ea typeface="Be Vietnam Pro" pitchFamily="34" charset="-122"/>
-                <a:cs typeface="Be Vietnam Pro" pitchFamily="34" charset="-120"/>
-              </a:rPr>
-              <a:t> thì</a:t>
-            </a:r>
-            <a:r>
-              <a:rPr lang="en-US" sz="2550" dirty="0" spc="-7" kern="0">
-                <a:solidFill>
-                  <a:srgbClr val="F3EEE3"/>
-                </a:solidFill>
-                <a:latin typeface="Be Vietnam Pro" pitchFamily="34" charset="0"/>
-                <a:ea typeface="Be Vietnam Pro" pitchFamily="34" charset="-122"/>
-                <a:cs typeface="Be Vietnam Pro" pitchFamily="34" charset="-120"/>
-              </a:rPr>
-              <a:t> sau</a:t>
-            </a:r>
-            <a:r>
-              <a:rPr lang="en-US" sz="2550" dirty="0" spc="-14" kern="0">
-                <a:solidFill>
-                  <a:srgbClr val="F3EEE3"/>
-                </a:solidFill>
-                <a:latin typeface="Be Vietnam Pro" pitchFamily="34" charset="0"/>
-                <a:ea typeface="Be Vietnam Pro" pitchFamily="34" charset="-122"/>
-                <a:cs typeface="Be Vietnam Pro" pitchFamily="34" charset="-120"/>
-              </a:rPr>
-              <a:t> vẫn</a:t>
-            </a:r>
-            <a:r>
-              <a:rPr lang="en-US" sz="2550" dirty="0" spc="-13" kern="0">
-                <a:solidFill>
-                  <a:srgbClr val="F3EEE3"/>
-                </a:solidFill>
-                <a:latin typeface="Be Vietnam Pro" pitchFamily="34" charset="0"/>
-                <a:ea typeface="Be Vietnam Pro" pitchFamily="34" charset="-122"/>
-                <a:cs typeface="Be Vietnam Pro" pitchFamily="34" charset="-120"/>
-              </a:rPr>
-              <a:t> tới</a:t>
-            </a:r>
-            <a:r>
-              <a:rPr lang="en-US" sz="2550" dirty="0" spc="1" kern="0">
-                <a:solidFill>
-                  <a:srgbClr val="F3EEE3"/>
-                </a:solidFill>
-                <a:latin typeface="Be Vietnam Pro" pitchFamily="34" charset="0"/>
-                <a:ea typeface="Be Vietnam Pro" pitchFamily="34" charset="-122"/>
-                <a:cs typeface="Be Vietnam Pro" pitchFamily="34" charset="-120"/>
-              </a:rPr>
-              <a:t> A</a:t>
+              <a:t>Sticky: cùng</a:t>
+            </a:r>
+            <a:r>
+              <a:rPr lang="en-US" sz="2550" dirty="0" spc="-6" kern="0">
+                <a:solidFill>
+                  <a:srgbClr val="F3EEE3"/>
+                </a:solidFill>
+                <a:latin typeface="Be Vietnam Pro" pitchFamily="34" charset="0"/>
+                <a:ea typeface="Be Vietnam Pro" pitchFamily="34" charset="-122"/>
+                <a:cs typeface="Be Vietnam Pro" pitchFamily="34" charset="-120"/>
+              </a:rPr>
+              <a:t> một</a:t>
+            </a:r>
+            <a:r>
+              <a:rPr lang="en-US" sz="2550" dirty="0" spc="0" kern="0">
+                <a:solidFill>
+                  <a:srgbClr val="F3EEE3"/>
+                </a:solidFill>
+                <a:latin typeface="Be Vietnam Pro" pitchFamily="34" charset="0"/>
+                <a:ea typeface="Be Vietnam Pro" pitchFamily="34" charset="-122"/>
+                <a:cs typeface="Be Vietnam Pro" pitchFamily="34" charset="-120"/>
+              </a:rPr>
+              <a:t> khách, cùng</a:t>
+            </a:r>
+            <a:r>
+              <a:rPr lang="en-US" sz="2550" dirty="0" spc="-6" kern="0">
+                <a:solidFill>
+                  <a:srgbClr val="F3EEE3"/>
+                </a:solidFill>
+                <a:latin typeface="Be Vietnam Pro" pitchFamily="34" charset="0"/>
+                <a:ea typeface="Be Vietnam Pro" pitchFamily="34" charset="-122"/>
+                <a:cs typeface="Be Vietnam Pro" pitchFamily="34" charset="-120"/>
+              </a:rPr>
+              <a:t> một</a:t>
+            </a:r>
+            <a:r>
+              <a:rPr lang="en-US" sz="2550" dirty="0" spc="-3" kern="0">
+                <a:solidFill>
+                  <a:srgbClr val="F3EEE3"/>
+                </a:solidFill>
+                <a:latin typeface="Be Vietnam Pro" pitchFamily="34" charset="0"/>
+                <a:ea typeface="Be Vietnam Pro" pitchFamily="34" charset="-122"/>
+                <a:cs typeface="Be Vietnam Pro" pitchFamily="34" charset="-120"/>
+              </a:rPr>
+              <a:t> bản</a:t>
+            </a:r>
+            <a:r>
+              <a:rPr lang="en-US" sz="2550" dirty="0" spc="-8" kern="0">
+                <a:solidFill>
+                  <a:srgbClr val="F3EEE3"/>
+                </a:solidFill>
+                <a:latin typeface="Be Vietnam Pro" pitchFamily="34" charset="0"/>
+                <a:ea typeface="Be Vietnam Pro" pitchFamily="34" charset="-122"/>
+                <a:cs typeface="Be Vietnam Pro" pitchFamily="34" charset="-120"/>
+              </a:rPr>
+              <a:t> sao</a:t>
             </a:r>
             <a:endParaRPr lang="en-US" sz="2550" dirty="0"/>
           </a:p>
@@ -6031,6 +6020,61 @@
               <a:buChar char="•"/>
             </a:pPr>
             <a:r>
+              <a:rPr lang="en-US" sz="2550" dirty="0" spc="0" kern="0">
+                <a:solidFill>
+                  <a:srgbClr val="F3EEE3"/>
+                </a:solidFill>
+                <a:latin typeface="Be Vietnam Pro" pitchFamily="34" charset="0"/>
+                <a:ea typeface="Be Vietnam Pro" pitchFamily="34" charset="-122"/>
+                <a:cs typeface="Be Vietnam Pro" pitchFamily="34" charset="-120"/>
+              </a:rPr>
+              <a:t>nginx</a:t>
+            </a:r>
+            <a:r>
+              <a:rPr lang="en-US" sz="2550" dirty="0" spc="-13" kern="0">
+                <a:solidFill>
+                  <a:srgbClr val="F3EEE3"/>
+                </a:solidFill>
+                <a:latin typeface="Be Vietnam Pro" pitchFamily="34" charset="0"/>
+                <a:ea typeface="Be Vietnam Pro" pitchFamily="34" charset="-122"/>
+                <a:cs typeface="Be Vietnam Pro" pitchFamily="34" charset="-120"/>
+              </a:rPr>
+              <a:t> gọi</a:t>
+            </a:r>
+            <a:r>
+              <a:rPr lang="en-US" sz="2550" dirty="0" spc="-4" kern="0">
+                <a:solidFill>
+                  <a:srgbClr val="F3EEE3"/>
+                </a:solidFill>
+                <a:latin typeface="Be Vietnam Pro" pitchFamily="34" charset="0"/>
+                <a:ea typeface="Be Vietnam Pro" pitchFamily="34" charset="-122"/>
+                <a:cs typeface="Be Vietnam Pro" pitchFamily="34" charset="-120"/>
+              </a:rPr>
+              <a:t> sticky</a:t>
+            </a:r>
+            <a:r>
+              <a:rPr lang="en-US" sz="2550" dirty="0" spc="1" kern="0">
+                <a:solidFill>
+                  <a:srgbClr val="F3EEE3"/>
+                </a:solidFill>
+                <a:latin typeface="Be Vietnam Pro" pitchFamily="34" charset="0"/>
+                <a:ea typeface="Be Vietnam Pro" pitchFamily="34" charset="-122"/>
+                <a:cs typeface="Be Vietnam Pro" pitchFamily="34" charset="-120"/>
+              </a:rPr>
+              <a:t> là</a:t>
+            </a:r>
+            <a:r>
+              <a:rPr lang="en-US" sz="2550" dirty="0" spc="-12" kern="0">
+                <a:solidFill>
+                  <a:srgbClr val="F3EEE3"/>
+                </a:solidFill>
+                <a:latin typeface="Be Vietnam Pro" pitchFamily="34" charset="0"/>
+                <a:ea typeface="Be Vietnam Pro" pitchFamily="34" charset="-122"/>
+                <a:cs typeface="Be Vietnam Pro" pitchFamily="34" charset="-120"/>
+              </a:rPr>
+              <a:t> gắn</a:t>
+            </a:r>
+            <a:r>
               <a:rPr lang="en-US" sz="2550" dirty="0" spc="-1" kern="0">
                 <a:solidFill>
                   <a:srgbClr val="F3EEE3"/>
@@ -6039,73 +6083,7 @@
                 <a:ea typeface="Be Vietnam Pro" pitchFamily="34" charset="-122"/>
                 <a:cs typeface="Be Vietnam Pro" pitchFamily="34" charset="-120"/>
               </a:rPr>
-              <a:t>Dịch</a:t>
-            </a:r>
-            <a:r>
-              <a:rPr lang="en-US" sz="2550" dirty="0" spc="-4" kern="0">
-                <a:solidFill>
-                  <a:srgbClr val="F3EEE3"/>
-                </a:solidFill>
-                <a:latin typeface="Be Vietnam Pro" pitchFamily="34" charset="0"/>
-                <a:ea typeface="Be Vietnam Pro" pitchFamily="34" charset="-122"/>
-                <a:cs typeface="Be Vietnam Pro" pitchFamily="34" charset="-120"/>
-              </a:rPr>
-              <a:t> vụ</a:t>
-            </a:r>
-            <a:r>
-              <a:rPr lang="en-US" sz="2550" dirty="0" spc="5" kern="0">
-                <a:solidFill>
-                  <a:srgbClr val="F3EEE3"/>
-                </a:solidFill>
-                <a:latin typeface="Be Vietnam Pro" pitchFamily="34" charset="0"/>
-                <a:ea typeface="Be Vietnam Pro" pitchFamily="34" charset="-122"/>
-                <a:cs typeface="Be Vietnam Pro" pitchFamily="34" charset="-120"/>
-              </a:rPr>
-              <a:t> thường</a:t>
-            </a:r>
-            <a:r>
-              <a:rPr lang="en-US" sz="2550" dirty="0" spc="0" kern="0">
-                <a:solidFill>
-                  <a:srgbClr val="F3EEE3"/>
-                </a:solidFill>
-                <a:latin typeface="Be Vietnam Pro" pitchFamily="34" charset="0"/>
-                <a:ea typeface="Be Vietnam Pro" pitchFamily="34" charset="-122"/>
-                <a:cs typeface="Be Vietnam Pro" pitchFamily="34" charset="-120"/>
-              </a:rPr>
-              <a:t> phải</a:t>
-            </a:r>
-            <a:r>
-              <a:rPr lang="en-US" sz="2550" dirty="0" spc="1" kern="0">
-                <a:solidFill>
-                  <a:srgbClr val="F3EEE3"/>
-                </a:solidFill>
-                <a:latin typeface="Be Vietnam Pro" pitchFamily="34" charset="0"/>
-                <a:ea typeface="Be Vietnam Pro" pitchFamily="34" charset="-122"/>
-                <a:cs typeface="Be Vietnam Pro" pitchFamily="34" charset="-120"/>
-              </a:rPr>
-              <a:t> là</a:t>
-            </a:r>
-            <a:r>
-              <a:rPr lang="en-US" sz="2550" dirty="0" spc="-3" kern="0">
-                <a:solidFill>
-                  <a:srgbClr val="F3EEE3"/>
-                </a:solidFill>
-                <a:latin typeface="Be Vietnam Pro" pitchFamily="34" charset="0"/>
-                <a:ea typeface="Be Vietnam Pro" pitchFamily="34" charset="-122"/>
-                <a:cs typeface="Be Vietnam Pro" pitchFamily="34" charset="-120"/>
-              </a:rPr>
-              <a:t> loại</a:t>
-            </a:r>
-            <a:r>
-              <a:rPr lang="en-US" sz="2550" dirty="0" spc="-18" kern="0">
-                <a:solidFill>
-                  <a:srgbClr val="F3EEE3"/>
-                </a:solidFill>
-                <a:latin typeface="Be Vietnam Pro" pitchFamily="34" charset="0"/>
-                <a:ea typeface="Be Vietnam Pro" pitchFamily="34" charset="-122"/>
-                <a:cs typeface="Be Vietnam Pro" pitchFamily="34" charset="-120"/>
-              </a:rPr>
-              <a:t> stateless</a:t>
+              <a:t> phiên</a:t>
             </a:r>
             <a:endParaRPr lang="en-US" sz="2550" dirty="0"/>
           </a:p>
@@ -6969,15 +6947,15 @@
               <a:buNone/>
             </a:pPr>
             <a:r>
-              <a:rPr lang="en-US" sz="2250" b="1" dirty="0" kern="0">
-                <a:solidFill>
-                  <a:srgbClr val="F3EEE3"/>
-                </a:solidFill>
-                <a:latin typeface="Be Vietnam Pro" pitchFamily="34" charset="0"/>
-                <a:ea typeface="Be Vietnam Pro" pitchFamily="34" charset="-122"/>
-                <a:cs typeface="Be Vietnam Pro" pitchFamily="34" charset="-120"/>
-              </a:rPr>
-              <a:t>Alice</a:t>
+              <a:rPr lang="en-US" sz="2250" b="1" dirty="0" spc="3" kern="0">
+                <a:solidFill>
+                  <a:srgbClr val="F3EEE3"/>
+                </a:solidFill>
+                <a:latin typeface="Be Vietnam Pro" pitchFamily="34" charset="0"/>
+                <a:ea typeface="Be Vietnam Pro" pitchFamily="34" charset="-122"/>
+                <a:cs typeface="Be Vietnam Pro" pitchFamily="34" charset="-120"/>
+              </a:rPr>
+              <a:t>Khách</a:t>
             </a:r>
             <a:endParaRPr lang="en-US" sz="2250" dirty="0"/>
           </a:p>
@@ -7356,7 +7334,7 @@
               <a:buNone/>
             </a:pPr>
             <a:r>
-              <a:rPr lang="en-US" sz="1950" dirty="0" spc="-22" kern="0">
+              <a:rPr lang="en-US" sz="1950" dirty="0" spc="-7" kern="0">
                 <a:solidFill>
                   <a:srgbClr val="C4C8D6"/>
                 </a:solidFill>
@@ -7364,7 +7342,95 @@
                 <a:ea typeface="Be Vietnam Pro" pitchFamily="34" charset="-122"/>
                 <a:cs typeface="Be Vietnam Pro" pitchFamily="34" charset="-120"/>
               </a:rPr>
-              <a:t>yêu</a:t>
+              <a:t>một</a:t>
+            </a:r>
+            <a:r>
+              <a:rPr lang="en-US" sz="1950" dirty="0" spc="-3" kern="0">
+                <a:solidFill>
+                  <a:srgbClr val="C4C8D6"/>
+                </a:solidFill>
+                <a:latin typeface="Be Vietnam Pro" pitchFamily="34" charset="0"/>
+                <a:ea typeface="Be Vietnam Pro" pitchFamily="34" charset="-122"/>
+                <a:cs typeface="Be Vietnam Pro" pitchFamily="34" charset="-120"/>
+              </a:rPr>
+              <a:t> khách:</a:t>
+            </a:r>
+            <a:r>
+              <a:rPr lang="en-US" sz="1950" dirty="0" spc="-16" kern="0">
+                <a:solidFill>
+                  <a:srgbClr val="C4C8D6"/>
+                </a:solidFill>
+                <a:latin typeface="Be Vietnam Pro" pitchFamily="34" charset="0"/>
+                <a:ea typeface="Be Vietnam Pro" pitchFamily="34" charset="-122"/>
+                <a:cs typeface="Be Vietnam Pro" pitchFamily="34" charset="-120"/>
+              </a:rPr>
+              <a:t> yêu</a:t>
+            </a:r>
+            <a:r>
+              <a:rPr lang="en-US" sz="1950" dirty="0" spc="-2" kern="0">
+                <a:solidFill>
+                  <a:srgbClr val="C4C8D6"/>
+                </a:solidFill>
+                <a:latin typeface="Be Vietnam Pro" pitchFamily="34" charset="0"/>
+                <a:ea typeface="Be Vietnam Pro" pitchFamily="34" charset="-122"/>
+                <a:cs typeface="Be Vietnam Pro" pitchFamily="34" charset="-120"/>
+              </a:rPr>
+              <a:t> cầu</a:t>
+            </a:r>
+            <a:r>
+              <a:rPr lang="en-US" sz="1950" dirty="0" spc="11" kern="0">
+                <a:solidFill>
+                  <a:srgbClr val="C4C8D6"/>
+                </a:solidFill>
+                <a:latin typeface="Be Vietnam Pro" pitchFamily="34" charset="0"/>
+                <a:ea typeface="Be Vietnam Pro" pitchFamily="34" charset="-122"/>
+                <a:cs typeface="Be Vietnam Pro" pitchFamily="34" charset="-120"/>
+              </a:rPr>
+              <a:t> đầu</a:t>
+            </a:r>
+            <a:r>
+              <a:rPr lang="en-US" sz="1950" dirty="0" spc="-11" kern="0">
+                <a:solidFill>
+                  <a:srgbClr val="C4C8D6"/>
+                </a:solidFill>
+                <a:latin typeface="Be Vietnam Pro" pitchFamily="34" charset="0"/>
+                <a:ea typeface="Be Vietnam Pro" pitchFamily="34" charset="-122"/>
+                <a:cs typeface="Be Vietnam Pro" pitchFamily="34" charset="-120"/>
+              </a:rPr>
+              <a:t> tới</a:t>
+            </a:r>
+            <a:r>
+              <a:rPr lang="en-US" sz="1950" dirty="0" spc="0" kern="0">
+                <a:solidFill>
+                  <a:srgbClr val="C4C8D6"/>
+                </a:solidFill>
+                <a:latin typeface="Be Vietnam Pro" pitchFamily="34" charset="0"/>
+                <a:ea typeface="Be Vietnam Pro" pitchFamily="34" charset="-122"/>
+                <a:cs typeface="Be Vietnam Pro" pitchFamily="34" charset="-120"/>
+              </a:rPr>
+              <a:t> A,</a:t>
+            </a:r>
+            <a:r>
+              <a:rPr lang="en-US" sz="1950" dirty="0" spc="-3" kern="0">
+                <a:solidFill>
+                  <a:srgbClr val="C4C8D6"/>
+                </a:solidFill>
+                <a:latin typeface="Be Vietnam Pro" pitchFamily="34" charset="0"/>
+                <a:ea typeface="Be Vietnam Pro" pitchFamily="34" charset="-122"/>
+                <a:cs typeface="Be Vietnam Pro" pitchFamily="34" charset="-120"/>
+              </a:rPr>
+              <a:t> các</a:t>
+            </a:r>
+            <a:r>
+              <a:rPr lang="en-US" sz="1950" dirty="0" spc="-17" kern="0">
+                <a:solidFill>
+                  <a:srgbClr val="C4C8D6"/>
+                </a:solidFill>
+                <a:latin typeface="Be Vietnam Pro" pitchFamily="34" charset="0"/>
+                <a:ea typeface="Be Vietnam Pro" pitchFamily="34" charset="-122"/>
+                <a:cs typeface="Be Vietnam Pro" pitchFamily="34" charset="-120"/>
+              </a:rPr>
+              <a:t> yêu</a:t>
             </a:r>
             <a:r>
               <a:rPr lang="en-US" sz="1950" dirty="0" spc="-1" kern="0">
@@ -7378,7 +7444,7 @@
               <a:t> cầu</a:t>
             </a:r>
             <a:r>
-              <a:rPr lang="en-US" sz="1950" dirty="0" spc="11" kern="0">
+              <a:rPr lang="en-US" sz="1950" dirty="0" spc="-3" kern="0">
                 <a:solidFill>
                   <a:srgbClr val="C4C8D6"/>
                 </a:solidFill>
@@ -7386,7 +7452,18 @@
                 <a:ea typeface="Be Vietnam Pro" pitchFamily="34" charset="-122"/>
                 <a:cs typeface="Be Vietnam Pro" pitchFamily="34" charset="-120"/>
               </a:rPr>
-              <a:t> đầu</a:t>
+              <a:t> sau</a:t>
+            </a:r>
+            <a:r>
+              <a:rPr lang="en-US" sz="1950" dirty="0" spc="1" kern="0">
+                <a:solidFill>
+                  <a:srgbClr val="C4C8D6"/>
+                </a:solidFill>
+                <a:latin typeface="Be Vietnam Pro" pitchFamily="34" charset="0"/>
+                <a:ea typeface="Be Vietnam Pro" pitchFamily="34" charset="-122"/>
+                <a:cs typeface="Be Vietnam Pro" pitchFamily="34" charset="-120"/>
+              </a:rPr>
+              <a:t> cũng</a:t>
             </a:r>
             <a:r>
               <a:rPr lang="en-US" sz="1950" dirty="0" spc="-11" kern="0">
@@ -7400,84 +7477,7 @@
               <a:t> tới</a:t>
             </a:r>
             <a:r>
-              <a:rPr lang="en-US" sz="1950" dirty="0" spc="0" kern="0">
-                <a:solidFill>
-                  <a:srgbClr val="C4C8D6"/>
-                </a:solidFill>
-                <a:latin typeface="Be Vietnam Pro" pitchFamily="34" charset="0"/>
-                <a:ea typeface="Be Vietnam Pro" pitchFamily="34" charset="-122"/>
-                <a:cs typeface="Be Vietnam Pro" pitchFamily="34" charset="-120"/>
-              </a:rPr>
-              <a:t> A,</a:t>
-            </a:r>
-            <a:r>
-              <a:rPr lang="en-US" sz="1950" dirty="0" spc="-3" kern="0">
-                <a:solidFill>
-                  <a:srgbClr val="C4C8D6"/>
-                </a:solidFill>
-                <a:latin typeface="Be Vietnam Pro" pitchFamily="34" charset="0"/>
-                <a:ea typeface="Be Vietnam Pro" pitchFamily="34" charset="-122"/>
-                <a:cs typeface="Be Vietnam Pro" pitchFamily="34" charset="-120"/>
-              </a:rPr>
-              <a:t> các</a:t>
-            </a:r>
-            <a:r>
-              <a:rPr lang="en-US" sz="1950" dirty="0" spc="-17" kern="0">
-                <a:solidFill>
-                  <a:srgbClr val="C4C8D6"/>
-                </a:solidFill>
-                <a:latin typeface="Be Vietnam Pro" pitchFamily="34" charset="0"/>
-                <a:ea typeface="Be Vietnam Pro" pitchFamily="34" charset="-122"/>
-                <a:cs typeface="Be Vietnam Pro" pitchFamily="34" charset="-120"/>
-              </a:rPr>
-              <a:t> yêu</a:t>
-            </a:r>
-            <a:r>
-              <a:rPr lang="en-US" sz="1950" dirty="0" spc="-1" kern="0">
-                <a:solidFill>
-                  <a:srgbClr val="C4C8D6"/>
-                </a:solidFill>
-                <a:latin typeface="Be Vietnam Pro" pitchFamily="34" charset="0"/>
-                <a:ea typeface="Be Vietnam Pro" pitchFamily="34" charset="-122"/>
-                <a:cs typeface="Be Vietnam Pro" pitchFamily="34" charset="-120"/>
-              </a:rPr>
-              <a:t> cầu</a:t>
-            </a:r>
-            <a:r>
-              <a:rPr lang="en-US" sz="1950" dirty="0" spc="-3" kern="0">
-                <a:solidFill>
-                  <a:srgbClr val="C4C8D6"/>
-                </a:solidFill>
-                <a:latin typeface="Be Vietnam Pro" pitchFamily="34" charset="0"/>
-                <a:ea typeface="Be Vietnam Pro" pitchFamily="34" charset="-122"/>
-                <a:cs typeface="Be Vietnam Pro" pitchFamily="34" charset="-120"/>
-              </a:rPr>
-              <a:t> sau</a:t>
-            </a:r>
-            <a:r>
-              <a:rPr lang="en-US" sz="1950" dirty="0" spc="1" kern="0">
-                <a:solidFill>
-                  <a:srgbClr val="C4C8D6"/>
-                </a:solidFill>
-                <a:latin typeface="Be Vietnam Pro" pitchFamily="34" charset="0"/>
-                <a:ea typeface="Be Vietnam Pro" pitchFamily="34" charset="-122"/>
-                <a:cs typeface="Be Vietnam Pro" pitchFamily="34" charset="-120"/>
-              </a:rPr>
-              <a:t> cũng</a:t>
-            </a:r>
-            <a:r>
-              <a:rPr lang="en-US" sz="1950" dirty="0" spc="-11" kern="0">
-                <a:solidFill>
-                  <a:srgbClr val="C4C8D6"/>
-                </a:solidFill>
-                <a:latin typeface="Be Vietnam Pro" pitchFamily="34" charset="0"/>
-                <a:ea typeface="Be Vietnam Pro" pitchFamily="34" charset="-122"/>
-                <a:cs typeface="Be Vietnam Pro" pitchFamily="34" charset="-120"/>
-              </a:rPr>
-              <a:t> tới</a:t>
-            </a:r>
-            <a:r>
-              <a:rPr lang="en-US" sz="1950" dirty="0" spc="-3" kern="0">
+              <a:rPr lang="en-US" sz="1950" dirty="0" spc="-2" kern="0">
                 <a:solidFill>
                   <a:srgbClr val="C4C8D6"/>
                 </a:solidFill>
@@ -8760,28 +8760,6 @@
               <a:buChar char="•"/>
             </a:pPr>
             <a:r>
-              <a:rPr lang="en-US" sz="2550" dirty="0" spc="-51" kern="0">
-                <a:solidFill>
-                  <a:srgbClr val="14161C"/>
-                </a:solidFill>
-                <a:latin typeface="Be Vietnam Pro" pitchFamily="34" charset="0"/>
-                <a:ea typeface="Be Vietnam Pro" pitchFamily="34" charset="-122"/>
-                <a:cs typeface="Be Vietnam Pro" pitchFamily="34" charset="-120"/>
-              </a:rPr>
-              <a:t>Kết</a:t>
-            </a:r>
-            <a:r>
-              <a:rPr lang="en-US" sz="2550" dirty="0" spc="2" kern="0">
-                <a:solidFill>
-                  <a:srgbClr val="14161C"/>
-                </a:solidFill>
-                <a:latin typeface="Be Vietnam Pro" pitchFamily="34" charset="0"/>
-                <a:ea typeface="Be Vietnam Pro" pitchFamily="34" charset="-122"/>
-                <a:cs typeface="Be Vietnam Pro" pitchFamily="34" charset="-120"/>
-              </a:rPr>
-              <a:t> quả</a:t>
-            </a:r>
-            <a:r>
               <a:rPr lang="en-US" sz="2550" dirty="0" spc="-2" kern="0">
                 <a:solidFill>
                   <a:srgbClr val="14161C"/>
@@ -8790,62 +8768,73 @@
                 <a:ea typeface="Be Vietnam Pro" pitchFamily="34" charset="-122"/>
                 <a:cs typeface="Be Vietnam Pro" pitchFamily="34" charset="-120"/>
               </a:rPr>
-              <a:t> băm</a:t>
-            </a:r>
-            <a:r>
-              <a:rPr lang="en-US" sz="2550" dirty="0" spc="-1" kern="0">
-                <a:solidFill>
-                  <a:srgbClr val="14161C"/>
-                </a:solidFill>
-                <a:latin typeface="Be Vietnam Pro" pitchFamily="34" charset="0"/>
-                <a:ea typeface="Be Vietnam Pro" pitchFamily="34" charset="-122"/>
-                <a:cs typeface="Be Vietnam Pro" pitchFamily="34" charset="-120"/>
-              </a:rPr>
-              <a:t> chọn</a:t>
-            </a:r>
-            <a:r>
-              <a:rPr lang="en-US" sz="2550" dirty="0" spc="-3" kern="0">
-                <a:solidFill>
-                  <a:srgbClr val="14161C"/>
-                </a:solidFill>
-                <a:latin typeface="Be Vietnam Pro" pitchFamily="34" charset="0"/>
-                <a:ea typeface="Be Vietnam Pro" pitchFamily="34" charset="-122"/>
-                <a:cs typeface="Be Vietnam Pro" pitchFamily="34" charset="-120"/>
-              </a:rPr>
-              <a:t> bản</a:t>
-            </a:r>
-            <a:r>
-              <a:rPr lang="en-US" sz="2550" dirty="0" spc="-8" kern="0">
-                <a:solidFill>
-                  <a:srgbClr val="14161C"/>
-                </a:solidFill>
-                <a:latin typeface="Be Vietnam Pro" pitchFamily="34" charset="0"/>
-                <a:ea typeface="Be Vietnam Pro" pitchFamily="34" charset="-122"/>
-                <a:cs typeface="Be Vietnam Pro" pitchFamily="34" charset="-120"/>
-              </a:rPr>
-              <a:t> sao</a:t>
-            </a:r>
-            <a:r>
-              <a:rPr lang="en-US" sz="2550" dirty="0" spc="6" kern="0">
-                <a:solidFill>
-                  <a:srgbClr val="14161C"/>
-                </a:solidFill>
-                <a:latin typeface="Be Vietnam Pro" pitchFamily="34" charset="0"/>
-                <a:ea typeface="Be Vietnam Pro" pitchFamily="34" charset="-122"/>
-                <a:cs typeface="Be Vietnam Pro" pitchFamily="34" charset="-120"/>
-              </a:rPr>
-              <a:t> tương</a:t>
-            </a:r>
-            <a:r>
-              <a:rPr lang="en-US" sz="2550" dirty="0" spc="24" kern="0">
-                <a:solidFill>
-                  <a:srgbClr val="14161C"/>
-                </a:solidFill>
-                <a:latin typeface="Be Vietnam Pro" pitchFamily="34" charset="0"/>
-                <a:ea typeface="Be Vietnam Pro" pitchFamily="34" charset="-122"/>
-                <a:cs typeface="Be Vietnam Pro" pitchFamily="34" charset="-120"/>
-              </a:rPr>
-              <a:t> ứng</a:t>
+              <a:t>Đổi</a:t>
+            </a:r>
+            <a:r>
+              <a:rPr lang="en-US" sz="2550" dirty="0" spc="-10" kern="0">
+                <a:solidFill>
+                  <a:srgbClr val="14161C"/>
+                </a:solidFill>
+                <a:latin typeface="Be Vietnam Pro" pitchFamily="34" charset="0"/>
+                <a:ea typeface="Be Vietnam Pro" pitchFamily="34" charset="-122"/>
+                <a:cs typeface="Be Vietnam Pro" pitchFamily="34" charset="-120"/>
+              </a:rPr>
+              <a:t> số</a:t>
+            </a:r>
+            <a:r>
+              <a:rPr lang="en-US" sz="2550" dirty="0" spc="-6" kern="0">
+                <a:solidFill>
+                  <a:srgbClr val="14161C"/>
+                </a:solidFill>
+                <a:latin typeface="Be Vietnam Pro" pitchFamily="34" charset="0"/>
+                <a:ea typeface="Be Vietnam Pro" pitchFamily="34" charset="-122"/>
+                <a:cs typeface="Be Vietnam Pro" pitchFamily="34" charset="-120"/>
+              </a:rPr>
+              <a:t> máy:</a:t>
+            </a:r>
+            <a:r>
+              <a:rPr lang="en-US" sz="2550" dirty="0" spc="0" kern="0">
+                <a:solidFill>
+                  <a:srgbClr val="14161C"/>
+                </a:solidFill>
+                <a:latin typeface="Be Vietnam Pro" pitchFamily="34" charset="0"/>
+                <a:ea typeface="Be Vietnam Pro" pitchFamily="34" charset="-122"/>
+                <a:cs typeface="Be Vietnam Pro" pitchFamily="34" charset="-120"/>
+              </a:rPr>
+              <a:t> nhiều</a:t>
+            </a:r>
+            <a:r>
+              <a:rPr lang="en-US" sz="2550" dirty="0" spc="-2" kern="0">
+                <a:solidFill>
+                  <a:srgbClr val="14161C"/>
+                </a:solidFill>
+                <a:latin typeface="Be Vietnam Pro" pitchFamily="34" charset="0"/>
+                <a:ea typeface="Be Vietnam Pro" pitchFamily="34" charset="-122"/>
+                <a:cs typeface="Be Vietnam Pro" pitchFamily="34" charset="-120"/>
+              </a:rPr>
+              <a:t> khóa</a:t>
+            </a:r>
+            <a:r>
+              <a:rPr lang="en-US" sz="2550" dirty="0" spc="1" kern="0">
+                <a:solidFill>
+                  <a:srgbClr val="14161C"/>
+                </a:solidFill>
+                <a:latin typeface="Be Vietnam Pro" pitchFamily="34" charset="0"/>
+                <a:ea typeface="Be Vietnam Pro" pitchFamily="34" charset="-122"/>
+                <a:cs typeface="Be Vietnam Pro" pitchFamily="34" charset="-120"/>
+              </a:rPr>
+              <a:t> bị</a:t>
+            </a:r>
+            <a:r>
+              <a:rPr lang="en-US" sz="2550" dirty="0" spc="-12" kern="0">
+                <a:solidFill>
+                  <a:srgbClr val="14161C"/>
+                </a:solidFill>
+                <a:latin typeface="Be Vietnam Pro" pitchFamily="34" charset="0"/>
+                <a:ea typeface="Be Vietnam Pro" pitchFamily="34" charset="-122"/>
+                <a:cs typeface="Be Vietnam Pro" pitchFamily="34" charset="-120"/>
+              </a:rPr>
+              <a:t> chuyển</a:t>
             </a:r>
             <a:endParaRPr lang="en-US" sz="2550" dirty="0"/>
           </a:p>
@@ -16683,37 +16672,26 @@
               <a:buChar char="•"/>
             </a:pPr>
             <a:r>
-              <a:rPr lang="en-US" sz="2550" dirty="0" spc="3" kern="0">
-                <a:solidFill>
-                  <a:srgbClr val="F3EEE3"/>
-                </a:solidFill>
-                <a:latin typeface="Be Vietnam Pro" pitchFamily="34" charset="0"/>
-                <a:ea typeface="Be Vietnam Pro" pitchFamily="34" charset="-122"/>
-                <a:cs typeface="Be Vietnam Pro" pitchFamily="34" charset="-120"/>
-              </a:rPr>
-              <a:t>Câu</a:t>
-            </a:r>
-            <a:r>
-              <a:rPr lang="en-US" sz="2550" dirty="0" spc="-18" kern="0">
-                <a:solidFill>
-                  <a:srgbClr val="F3EEE3"/>
-                </a:solidFill>
-                <a:latin typeface="Be Vietnam Pro" pitchFamily="34" charset="0"/>
-                <a:ea typeface="Be Vietnam Pro" pitchFamily="34" charset="-122"/>
-                <a:cs typeface="Be Vietnam Pro" pitchFamily="34" charset="-120"/>
-              </a:rPr>
-              <a:t> về stateless</a:t>
-            </a:r>
-            <a:r>
-              <a:rPr lang="en-US" sz="2550" dirty="0" spc="6" kern="0">
-                <a:solidFill>
-                  <a:srgbClr val="F3EEE3"/>
-                </a:solidFill>
-                <a:latin typeface="Be Vietnam Pro" pitchFamily="34" charset="0"/>
-                <a:ea typeface="Be Vietnam Pro" pitchFamily="34" charset="-122"/>
-                <a:cs typeface="Be Vietnam Pro" pitchFamily="34" charset="-120"/>
-              </a:rPr>
-              <a:t> chưa được</a:t>
+              <a:rPr lang="en-US" sz="2550" dirty="0" spc="-25" kern="0">
+                <a:solidFill>
+                  <a:srgbClr val="F3EEE3"/>
+                </a:solidFill>
+                <a:latin typeface="Be Vietnam Pro" pitchFamily="34" charset="0"/>
+                <a:ea typeface="Be Vietnam Pro" pitchFamily="34" charset="-122"/>
+                <a:cs typeface="Be Vietnam Pro" pitchFamily="34" charset="-120"/>
+              </a:rPr>
+              <a:t>HAProxy</a:t>
+            </a:r>
+            <a:r>
+              <a:rPr lang="en-US" sz="2550" dirty="0" spc="0" kern="0">
+                <a:solidFill>
+                  <a:srgbClr val="F3EEE3"/>
+                </a:solidFill>
+                <a:latin typeface="Be Vietnam Pro" pitchFamily="34" charset="0"/>
+                <a:ea typeface="Be Vietnam Pro" pitchFamily="34" charset="-122"/>
+                <a:cs typeface="Be Vietnam Pro" pitchFamily="34" charset="-120"/>
+              </a:rPr>
+              <a:t> hiểu</a:t>
             </a:r>
             <a:r>
               <a:rPr lang="en-US" sz="2550" dirty="0" spc="1" kern="0">
@@ -16724,18 +16702,29 @@
                 <a:ea typeface="Be Vietnam Pro" pitchFamily="34" charset="-122"/>
                 <a:cs typeface="Be Vietnam Pro" pitchFamily="34" charset="-120"/>
               </a:rPr>
-              <a:t> kiểm</a:t>
-            </a:r>
-            <a:r>
-              <a:rPr lang="en-US" sz="2550" dirty="0" spc="-25" kern="0">
-                <a:solidFill>
-                  <a:srgbClr val="F3EEE3"/>
-                </a:solidFill>
-                <a:latin typeface="Be Vietnam Pro" pitchFamily="34" charset="0"/>
-                <a:ea typeface="Be Vietnam Pro" pitchFamily="34" charset="-122"/>
-                <a:cs typeface="Be Vietnam Pro" pitchFamily="34" charset="-120"/>
-              </a:rPr>
-              <a:t> tra</a:t>
+              <a:t> tĩnh,</a:t>
+            </a:r>
+            <a:r>
+              <a:rPr lang="en-US" sz="2550" dirty="0" spc="10" kern="0">
+                <a:solidFill>
+                  <a:srgbClr val="F3EEE3"/>
+                </a:solidFill>
+                <a:latin typeface="Be Vietnam Pro" pitchFamily="34" charset="0"/>
+                <a:ea typeface="Be Vietnam Pro" pitchFamily="34" charset="-122"/>
+                <a:cs typeface="Be Vietnam Pro" pitchFamily="34" charset="-120"/>
+              </a:rPr>
+              <a:t> động</a:t>
+            </a:r>
+            <a:r>
+              <a:rPr lang="en-US" sz="2550" dirty="0" spc="1" kern="0">
+                <a:solidFill>
+                  <a:srgbClr val="F3EEE3"/>
+                </a:solidFill>
+                <a:latin typeface="Be Vietnam Pro" pitchFamily="34" charset="0"/>
+                <a:ea typeface="Be Vietnam Pro" pitchFamily="34" charset="-122"/>
+                <a:cs typeface="Be Vietnam Pro" pitchFamily="34" charset="-120"/>
+              </a:rPr>
+              <a:t> khác</a:t>
             </a:r>
             <a:endParaRPr lang="en-US" sz="2550" dirty="0"/>
           </a:p>
@@ -17570,7 +17559,7 @@
               <a:buNone/>
             </a:pPr>
             <a:r>
-              <a:rPr lang="en-US" sz="1800" b="1" spc="224" kern="0" dirty="0">
+              <a:rPr lang="en-US" sz="1800" b="1" spc="222" kern="0" dirty="0">
                 <a:solidFill>
                   <a:srgbClr val="3DD6A0"/>
                 </a:solidFill>
@@ -17578,10 +17567,10 @@
                 <a:ea typeface="Be Vietnam Pro" pitchFamily="34" charset="-122"/>
                 <a:cs typeface="Be Vietnam Pro" pitchFamily="34" charset="-120"/>
               </a:rPr>
-              <a:t>PHẦN</a:t>
-            </a:r>
-            <a:r>
-              <a:rPr lang="en-US" sz="1800" b="1" spc="223" kern="0" dirty="0">
+              <a:t>NGINX</a:t>
+            </a:r>
+            <a:r>
+              <a:rPr lang="en-US" sz="1800" b="1" spc="179" kern="0" dirty="0">
                 <a:solidFill>
                   <a:srgbClr val="3DD6A0"/>
                 </a:solidFill>
@@ -17589,7 +17578,18 @@
                 <a:ea typeface="Be Vietnam Pro" pitchFamily="34" charset="-122"/>
                 <a:cs typeface="Be Vietnam Pro" pitchFamily="34" charset="-120"/>
               </a:rPr>
-              <a:t> NGINX</a:t>
+              <a:t> VÀ</a:t>
+            </a:r>
+            <a:r>
+              <a:rPr lang="en-US" sz="1800" b="1" spc="208" kern="0" dirty="0">
+                <a:solidFill>
+                  <a:srgbClr val="3DD6A0"/>
+                </a:solidFill>
+                <a:latin typeface="Be Vietnam Pro" pitchFamily="34" charset="0"/>
+                <a:ea typeface="Be Vietnam Pro" pitchFamily="34" charset="-122"/>
+                <a:cs typeface="Be Vietnam Pro" pitchFamily="34" charset="-120"/>
+              </a:rPr>
+              <a:t> HAPROXY</a:t>
             </a:r>
             <a:endParaRPr lang="en-US" sz="1800" dirty="0"/>
           </a:p>
@@ -18735,26 +18735,15 @@
               <a:buNone/>
             </a:pPr>
             <a:r>
-              <a:rPr lang="en-US" sz="2700" dirty="0" spc="-8" kern="0">
-                <a:solidFill>
-                  <a:srgbClr val="14161C"/>
-                </a:solidFill>
-                <a:latin typeface="Be Vietnam Pro" pitchFamily="34" charset="0"/>
-                <a:ea typeface="Be Vietnam Pro" pitchFamily="34" charset="-122"/>
-                <a:cs typeface="Be Vietnam Pro" pitchFamily="34" charset="-120"/>
-              </a:rPr>
-              <a:t>Thuật</a:t>
-            </a:r>
-            <a:r>
-              <a:rPr lang="en-US" sz="2700" dirty="0" spc="-15" kern="0">
-                <a:solidFill>
-                  <a:srgbClr val="14161C"/>
-                </a:solidFill>
-                <a:latin typeface="Be Vietnam Pro" pitchFamily="34" charset="0"/>
-                <a:ea typeface="Be Vietnam Pro" pitchFamily="34" charset="-122"/>
-                <a:cs typeface="Be Vietnam Pro" pitchFamily="34" charset="-120"/>
-              </a:rPr>
-              <a:t> toán</a:t>
+              <a:rPr lang="en-US" sz="2700" dirty="0" spc="-7" kern="0">
+                <a:solidFill>
+                  <a:srgbClr val="14161C"/>
+                </a:solidFill>
+                <a:latin typeface="Be Vietnam Pro" pitchFamily="34" charset="0"/>
+                <a:ea typeface="Be Vietnam Pro" pitchFamily="34" charset="-122"/>
+                <a:cs typeface="Be Vietnam Pro" pitchFamily="34" charset="-120"/>
+              </a:rPr>
+              <a:t>Một</a:t>
             </a:r>
             <a:r>
               <a:rPr lang="en-US" sz="2700" dirty="0" spc="-2" kern="0">
@@ -18765,7 +18754,139 @@
                 <a:ea typeface="Be Vietnam Pro" pitchFamily="34" charset="-122"/>
                 <a:cs typeface="Be Vietnam Pro" pitchFamily="34" charset="-120"/>
               </a:rPr>
-              <a:t> nào giữ</a:t>
+              <a:t> nhóm</a:t>
+            </a:r>
+            <a:r>
+              <a:rPr lang="en-US" sz="2700" dirty="0" spc="-3" kern="0">
+                <a:solidFill>
+                  <a:srgbClr val="14161C"/>
+                </a:solidFill>
+                <a:latin typeface="Be Vietnam Pro" pitchFamily="34" charset="0"/>
+                <a:ea typeface="Be Vietnam Pro" pitchFamily="34" charset="-122"/>
+                <a:cs typeface="Be Vietnam Pro" pitchFamily="34" charset="-120"/>
+              </a:rPr>
+              <a:t> dùng ip_hash</a:t>
+            </a:r>
+            <a:r>
+              <a:rPr lang="en-US" sz="2700" dirty="0" spc="10" kern="0">
+                <a:solidFill>
+                  <a:srgbClr val="14161C"/>
+                </a:solidFill>
+                <a:latin typeface="Be Vietnam Pro" pitchFamily="34" charset="0"/>
+                <a:ea typeface="Be Vietnam Pro" pitchFamily="34" charset="-122"/>
+                <a:cs typeface="Be Vietnam Pro" pitchFamily="34" charset="-120"/>
+              </a:rPr>
+              <a:t> được</a:t>
+            </a:r>
+            <a:r>
+              <a:rPr lang="en-US" sz="2700" dirty="0" spc="-2" kern="0">
+                <a:solidFill>
+                  <a:srgbClr val="14161C"/>
+                </a:solidFill>
+                <a:latin typeface="Be Vietnam Pro" pitchFamily="34" charset="0"/>
+                <a:ea typeface="Be Vietnam Pro" pitchFamily="34" charset="-122"/>
+                <a:cs typeface="Be Vietnam Pro" pitchFamily="34" charset="-120"/>
+              </a:rPr>
+              <a:t> thêm</a:t>
+            </a:r>
+            <a:r>
+              <a:rPr lang="en-US" sz="2700" dirty="0" spc="-7" kern="0">
+                <a:solidFill>
+                  <a:srgbClr val="14161C"/>
+                </a:solidFill>
+                <a:latin typeface="Be Vietnam Pro" pitchFamily="34" charset="0"/>
+                <a:ea typeface="Be Vietnam Pro" pitchFamily="34" charset="-122"/>
+                <a:cs typeface="Be Vietnam Pro" pitchFamily="34" charset="-120"/>
+              </a:rPr>
+              <a:t> một</a:t>
+            </a:r>
+            <a:r>
+              <a:rPr lang="en-US" sz="2700" dirty="0" spc="-10" kern="0">
+                <a:solidFill>
+                  <a:srgbClr val="14161C"/>
+                </a:solidFill>
+                <a:latin typeface="Be Vietnam Pro" pitchFamily="34" charset="0"/>
+                <a:ea typeface="Be Vietnam Pro" pitchFamily="34" charset="-122"/>
+                <a:cs typeface="Be Vietnam Pro" pitchFamily="34" charset="-120"/>
+              </a:rPr>
+              <a:t> máy:</a:t>
+            </a:r>
+            <a:r>
+              <a:rPr lang="en-US" sz="2700" dirty="0" spc="21" kern="0">
+                <a:solidFill>
+                  <a:srgbClr val="14161C"/>
+                </a:solidFill>
+                <a:latin typeface="Be Vietnam Pro" pitchFamily="34" charset="0"/>
+                <a:ea typeface="Be Vietnam Pro" pitchFamily="34" charset="-122"/>
+                <a:cs typeface="Be Vietnam Pro" pitchFamily="34" charset="-120"/>
+              </a:rPr>
+              <a:t> điều</a:t>
+            </a:r>
+            <a:r>
+              <a:rPr lang="en-US" sz="2700" dirty="0" spc="-4" kern="0">
+                <a:solidFill>
+                  <a:srgbClr val="14161C"/>
+                </a:solidFill>
+                <a:latin typeface="Be Vietnam Pro" pitchFamily="34" charset="0"/>
+                <a:ea typeface="Be Vietnam Pro" pitchFamily="34" charset="-122"/>
+                <a:cs typeface="Be Vietnam Pro" pitchFamily="34" charset="-120"/>
+              </a:rPr>
+              <a:t> gì</a:t>
+            </a:r>
+            <a:r>
+              <a:rPr lang="en-US" sz="2700" dirty="0" spc="0" kern="0">
+                <a:solidFill>
+                  <a:srgbClr val="14161C"/>
+                </a:solidFill>
+                <a:latin typeface="Be Vietnam Pro" pitchFamily="34" charset="0"/>
+                <a:ea typeface="Be Vietnam Pro" pitchFamily="34" charset="-122"/>
+                <a:cs typeface="Be Vietnam Pro" pitchFamily="34" charset="-120"/>
+              </a:rPr>
+              <a:t> có</a:t>
+            </a:r>
+            <a:r>
+              <a:rPr lang="en-US" sz="2700" dirty="0" spc="-1" kern="0">
+                <a:solidFill>
+                  <a:srgbClr val="14161C"/>
+                </a:solidFill>
+                <a:latin typeface="Be Vietnam Pro" pitchFamily="34" charset="0"/>
+                <a:ea typeface="Be Vietnam Pro" pitchFamily="34" charset="-122"/>
+                <a:cs typeface="Be Vietnam Pro" pitchFamily="34" charset="-120"/>
+              </a:rPr>
+              <a:t> thể</a:t>
+            </a:r>
+            <a:r>
+              <a:rPr lang="en-US" sz="2700" dirty="0" spc="-33" kern="0">
+                <a:solidFill>
+                  <a:srgbClr val="14161C"/>
+                </a:solidFill>
+                <a:latin typeface="Be Vietnam Pro" pitchFamily="34" charset="0"/>
+                <a:ea typeface="Be Vietnam Pro" pitchFamily="34" charset="-122"/>
+                <a:cs typeface="Be Vietnam Pro" pitchFamily="34" charset="-120"/>
+              </a:rPr>
+              <a:t> xảy</a:t>
+            </a:r>
+            <a:r>
+              <a:rPr lang="en-US" sz="2700" dirty="0" spc="-40" kern="0">
+                <a:solidFill>
+                  <a:srgbClr val="14161C"/>
+                </a:solidFill>
+                <a:latin typeface="Be Vietnam Pro" pitchFamily="34" charset="0"/>
+                <a:ea typeface="Be Vietnam Pro" pitchFamily="34" charset="-122"/>
+                <a:cs typeface="Be Vietnam Pro" pitchFamily="34" charset="-120"/>
+              </a:rPr>
+              <a:t> ra</a:t>
+            </a:r>
+            <a:r>
+              <a:rPr lang="en-US" sz="2700" dirty="0" spc="-13" kern="0">
+                <a:solidFill>
+                  <a:srgbClr val="14161C"/>
+                </a:solidFill>
+                <a:latin typeface="Be Vietnam Pro" pitchFamily="34" charset="0"/>
+                <a:ea typeface="Be Vietnam Pro" pitchFamily="34" charset="-122"/>
+                <a:cs typeface="Be Vietnam Pro" pitchFamily="34" charset="-120"/>
+              </a:rPr>
+              <a:t> với</a:t>
             </a:r>
             <a:r>
               <a:rPr lang="en-US" sz="2700" dirty="0" spc="1" kern="0">
@@ -18776,139 +18897,18 @@
                 <a:ea typeface="Be Vietnam Pro" pitchFamily="34" charset="-122"/>
                 <a:cs typeface="Be Vietnam Pro" pitchFamily="34" charset="-120"/>
               </a:rPr>
-              <a:t> Alice</a:t>
-            </a:r>
-            <a:r>
-              <a:rPr lang="en-US" sz="2700" dirty="0" spc="-3" kern="0">
-                <a:solidFill>
-                  <a:srgbClr val="14161C"/>
-                </a:solidFill>
-                <a:latin typeface="Be Vietnam Pro" pitchFamily="34" charset="0"/>
-                <a:ea typeface="Be Vietnam Pro" pitchFamily="34" charset="-122"/>
-                <a:cs typeface="Be Vietnam Pro" pitchFamily="34" charset="-120"/>
-              </a:rPr>
-              <a:t> ở</a:t>
-            </a:r>
-            <a:r>
-              <a:rPr lang="en-US" sz="2700" dirty="0" spc="-2" kern="0">
-                <a:solidFill>
-                  <a:srgbClr val="14161C"/>
-                </a:solidFill>
-                <a:latin typeface="Be Vietnam Pro" pitchFamily="34" charset="0"/>
-                <a:ea typeface="Be Vietnam Pro" pitchFamily="34" charset="-122"/>
-                <a:cs typeface="Be Vietnam Pro" pitchFamily="34" charset="-120"/>
-              </a:rPr>
-              <a:t> cùng</a:t>
-            </a:r>
-            <a:r>
-              <a:rPr lang="en-US" sz="2700" dirty="0" spc="-7" kern="0">
-                <a:solidFill>
-                  <a:srgbClr val="14161C"/>
-                </a:solidFill>
-                <a:latin typeface="Be Vietnam Pro" pitchFamily="34" charset="0"/>
-                <a:ea typeface="Be Vietnam Pro" pitchFamily="34" charset="-122"/>
-                <a:cs typeface="Be Vietnam Pro" pitchFamily="34" charset="-120"/>
-              </a:rPr>
-              <a:t> một</a:t>
-            </a:r>
-            <a:r>
-              <a:rPr lang="en-US" sz="2700" dirty="0" spc="-1" kern="0">
-                <a:solidFill>
-                  <a:srgbClr val="14161C"/>
-                </a:solidFill>
-                <a:latin typeface="Be Vietnam Pro" pitchFamily="34" charset="0"/>
-                <a:ea typeface="Be Vietnam Pro" pitchFamily="34" charset="-122"/>
-                <a:cs typeface="Be Vietnam Pro" pitchFamily="34" charset="-120"/>
-              </a:rPr>
-              <a:t> dịch vụ cho</a:t>
-            </a:r>
-            <a:r>
-              <a:rPr lang="en-US" sz="2700" dirty="0" spc="-2" kern="0">
-                <a:solidFill>
-                  <a:srgbClr val="14161C"/>
-                </a:solidFill>
-                <a:latin typeface="Be Vietnam Pro" pitchFamily="34" charset="0"/>
-                <a:ea typeface="Be Vietnam Pro" pitchFamily="34" charset="-122"/>
-                <a:cs typeface="Be Vietnam Pro" pitchFamily="34" charset="-120"/>
-              </a:rPr>
-              <a:t> mọi</a:t>
-            </a:r>
-            <a:r>
-              <a:rPr lang="en-US" sz="2700" dirty="0" spc="-26" kern="0">
-                <a:solidFill>
-                  <a:srgbClr val="14161C"/>
-                </a:solidFill>
-                <a:latin typeface="Be Vietnam Pro" pitchFamily="34" charset="0"/>
-                <a:ea typeface="Be Vietnam Pro" pitchFamily="34" charset="-122"/>
-                <a:cs typeface="Be Vietnam Pro" pitchFamily="34" charset="-120"/>
-              </a:rPr>
-              <a:t> yêu</a:t>
-            </a:r>
-            <a:r>
-              <a:rPr lang="en-US" sz="2700" dirty="0" spc="2" kern="0">
-                <a:solidFill>
-                  <a:srgbClr val="14161C"/>
-                </a:solidFill>
-                <a:latin typeface="Be Vietnam Pro" pitchFamily="34" charset="0"/>
-                <a:ea typeface="Be Vietnam Pro" pitchFamily="34" charset="-122"/>
-                <a:cs typeface="Be Vietnam Pro" pitchFamily="34" charset="-120"/>
-              </a:rPr>
-              <a:t> cầu</a:t>
-            </a:r>
-            <a:r>
-              <a:rPr lang="en-US" sz="2700" dirty="0" spc="-9" kern="0">
-                <a:solidFill>
-                  <a:srgbClr val="14161C"/>
-                </a:solidFill>
-                <a:latin typeface="Be Vietnam Pro" pitchFamily="34" charset="0"/>
-                <a:ea typeface="Be Vietnam Pro" pitchFamily="34" charset="-122"/>
-                <a:cs typeface="Be Vietnam Pro" pitchFamily="34" charset="-120"/>
-              </a:rPr>
-              <a:t> sau</a:t>
-            </a:r>
-            <a:r>
-              <a:rPr lang="en-US" sz="2700" dirty="0" spc="-26" kern="0">
-                <a:solidFill>
-                  <a:srgbClr val="14161C"/>
-                </a:solidFill>
-                <a:latin typeface="Be Vietnam Pro" pitchFamily="34" charset="0"/>
-                <a:ea typeface="Be Vietnam Pro" pitchFamily="34" charset="-122"/>
-                <a:cs typeface="Be Vietnam Pro" pitchFamily="34" charset="-120"/>
-              </a:rPr>
-              <a:t> yêu</a:t>
-            </a:r>
-            <a:r>
-              <a:rPr lang="en-US" sz="2700" dirty="0" spc="2" kern="0">
-                <a:solidFill>
-                  <a:srgbClr val="14161C"/>
-                </a:solidFill>
-                <a:latin typeface="Be Vietnam Pro" pitchFamily="34" charset="0"/>
-                <a:ea typeface="Be Vietnam Pro" pitchFamily="34" charset="-122"/>
-                <a:cs typeface="Be Vietnam Pro" pitchFamily="34" charset="-120"/>
-              </a:rPr>
-              <a:t> cầu</a:t>
-            </a:r>
-            <a:r>
-              <a:rPr lang="en-US" sz="2700" dirty="0" spc="13" kern="0">
-                <a:solidFill>
-                  <a:srgbClr val="14161C"/>
-                </a:solidFill>
-                <a:latin typeface="Be Vietnam Pro" pitchFamily="34" charset="0"/>
-                <a:ea typeface="Be Vietnam Pro" pitchFamily="34" charset="-122"/>
-                <a:cs typeface="Be Vietnam Pro" pitchFamily="34" charset="-120"/>
-              </a:rPr>
-              <a:t> đầu</a:t>
-            </a:r>
-            <a:r>
-              <a:rPr lang="en-US" sz="2700" dirty="0" spc="-2" kern="0">
-                <a:solidFill>
-                  <a:srgbClr val="14161C"/>
-                </a:solidFill>
-                <a:latin typeface="Be Vietnam Pro" pitchFamily="34" charset="0"/>
-                <a:ea typeface="Be Vietnam Pro" pitchFamily="34" charset="-122"/>
-                <a:cs typeface="Be Vietnam Pro" pitchFamily="34" charset="-120"/>
-              </a:rPr>
-              <a:t> tiên?</a:t>
+              <a:t> các</a:t>
+            </a:r>
+            <a:r>
+              <a:rPr lang="en-US" sz="2700" dirty="0" spc="0" kern="0">
+                <a:solidFill>
+                  <a:srgbClr val="14161C"/>
+                </a:solidFill>
+                <a:latin typeface="Be Vietnam Pro" pitchFamily="34" charset="0"/>
+                <a:ea typeface="Be Vietnam Pro" pitchFamily="34" charset="-122"/>
+                <a:cs typeface="Be Vietnam Pro" pitchFamily="34" charset="-120"/>
+              </a:rPr>
+              <a:t> khách?</a:t>
             </a:r>
             <a:endParaRPr lang="en-US" sz="2700" dirty="0"/>
           </a:p>
@@ -19747,7 +19747,7 @@
               <a:buNone/>
             </a:pPr>
             <a:r>
-              <a:rPr lang="en-US" sz="3000" b="1" dirty="0" spc="0" kern="0">
+              <a:rPr lang="en-US" sz="3000" b="1" dirty="0" spc="-1" kern="0">
                 <a:solidFill>
                   <a:srgbClr val="1F3FD1"/>
                 </a:solidFill>
@@ -19755,10 +19755,10 @@
                 <a:ea typeface="Be Vietnam Pro" pitchFamily="34" charset="-122"/>
                 <a:cs typeface="Be Vietnam Pro" pitchFamily="34" charset="-120"/>
               </a:rPr>
-              <a:t>Sticky</a:t>
-            </a:r>
-            <a:r>
-              <a:rPr lang="en-US" sz="3000" b="1" dirty="0" spc="-15" kern="0">
+              <a:t>Khách</a:t>
+            </a:r>
+            <a:r>
+              <a:rPr lang="en-US" sz="3000" b="1" dirty="0" spc="5" kern="0">
                 <a:solidFill>
                   <a:srgbClr val="1F3FD1"/>
                 </a:solidFill>
@@ -19766,7 +19766,18 @@
                 <a:ea typeface="Be Vietnam Pro" pitchFamily="34" charset="-122"/>
                 <a:cs typeface="Be Vietnam Pro" pitchFamily="34" charset="-120"/>
               </a:rPr>
-              <a:t> round-robin</a:t>
+              <a:t> bị</a:t>
+            </a:r>
+            <a:r>
+              <a:rPr lang="en-US" sz="3000" b="1" dirty="0" spc="-16" kern="0">
+                <a:solidFill>
+                  <a:srgbClr val="1F3FD1"/>
+                </a:solidFill>
+                <a:latin typeface="Be Vietnam Pro" pitchFamily="34" charset="0"/>
+                <a:ea typeface="Be Vietnam Pro" pitchFamily="34" charset="-122"/>
+                <a:cs typeface="Be Vietnam Pro" pitchFamily="34" charset="-120"/>
+              </a:rPr>
+              <a:t> chuyển</a:t>
             </a:r>
             <a:endParaRPr lang="en-US" sz="3000" dirty="0"/>
           </a:p>
@@ -19800,6 +19811,83 @@
               <a:buNone/>
             </a:pPr>
             <a:r>
+              <a:rPr lang="en-US" sz="2250" dirty="0" spc="-46" kern="0">
+                <a:solidFill>
+                  <a:srgbClr val="14161C"/>
+                </a:solidFill>
+                <a:latin typeface="Be Vietnam Pro" pitchFamily="34" charset="0"/>
+                <a:ea typeface="Be Vietnam Pro" pitchFamily="34" charset="-122"/>
+                <a:cs typeface="Be Vietnam Pro" pitchFamily="34" charset="-120"/>
+              </a:rPr>
+              <a:t>Kết</a:t>
+            </a:r>
+            <a:r>
+              <a:rPr lang="en-US" sz="2250" dirty="0" spc="1" kern="0">
+                <a:solidFill>
+                  <a:srgbClr val="14161C"/>
+                </a:solidFill>
+                <a:latin typeface="Be Vietnam Pro" pitchFamily="34" charset="0"/>
+                <a:ea typeface="Be Vietnam Pro" pitchFamily="34" charset="-122"/>
+                <a:cs typeface="Be Vietnam Pro" pitchFamily="34" charset="-120"/>
+              </a:rPr>
+              <a:t> quả</a:t>
+            </a:r>
+            <a:r>
+              <a:rPr lang="en-US" sz="2250" dirty="0" spc="-3" kern="0">
+                <a:solidFill>
+                  <a:srgbClr val="14161C"/>
+                </a:solidFill>
+                <a:latin typeface="Be Vietnam Pro" pitchFamily="34" charset="0"/>
+                <a:ea typeface="Be Vietnam Pro" pitchFamily="34" charset="-122"/>
+                <a:cs typeface="Be Vietnam Pro" pitchFamily="34" charset="-120"/>
+              </a:rPr>
+              <a:t> băm</a:t>
+            </a:r>
+            <a:r>
+              <a:rPr lang="en-US" sz="2250" dirty="0" spc="13" kern="0">
+                <a:solidFill>
+                  <a:srgbClr val="14161C"/>
+                </a:solidFill>
+                <a:latin typeface="Be Vietnam Pro" pitchFamily="34" charset="0"/>
+                <a:ea typeface="Be Vietnam Pro" pitchFamily="34" charset="-122"/>
+                <a:cs typeface="Be Vietnam Pro" pitchFamily="34" charset="-120"/>
+              </a:rPr>
+              <a:t> đổi</a:t>
+            </a:r>
+            <a:r>
+              <a:rPr lang="en-US" sz="2250" dirty="0" spc="-3" kern="0">
+                <a:solidFill>
+                  <a:srgbClr val="14161C"/>
+                </a:solidFill>
+                <a:latin typeface="Be Vietnam Pro" pitchFamily="34" charset="0"/>
+                <a:ea typeface="Be Vietnam Pro" pitchFamily="34" charset="-122"/>
+                <a:cs typeface="Be Vietnam Pro" pitchFamily="34" charset="-120"/>
+              </a:rPr>
+              <a:t> theo</a:t>
+            </a:r>
+            <a:r>
+              <a:rPr lang="en-US" sz="2250" dirty="0" spc="-2" kern="0">
+                <a:solidFill>
+                  <a:srgbClr val="14161C"/>
+                </a:solidFill>
+                <a:latin typeface="Be Vietnam Pro" pitchFamily="34" charset="0"/>
+                <a:ea typeface="Be Vietnam Pro" pitchFamily="34" charset="-122"/>
+                <a:cs typeface="Be Vietnam Pro" pitchFamily="34" charset="-120"/>
+              </a:rPr>
+              <a:t> số</a:t>
+            </a:r>
+            <a:r>
+              <a:rPr lang="en-US" sz="2250" dirty="0" spc="-9" kern="0">
+                <a:solidFill>
+                  <a:srgbClr val="14161C"/>
+                </a:solidFill>
+                <a:latin typeface="Be Vietnam Pro" pitchFamily="34" charset="0"/>
+                <a:ea typeface="Be Vietnam Pro" pitchFamily="34" charset="-122"/>
+                <a:cs typeface="Be Vietnam Pro" pitchFamily="34" charset="-120"/>
+              </a:rPr>
+              <a:t> máy;</a:t>
+            </a:r>
+            <a:r>
               <a:rPr lang="en-US" sz="2250" dirty="0" spc="-1" kern="0">
                 <a:solidFill>
                   <a:srgbClr val="14161C"/>
@@ -19808,7 +19896,51 @@
                 <a:ea typeface="Be Vietnam Pro" pitchFamily="34" charset="-122"/>
                 <a:cs typeface="Be Vietnam Pro" pitchFamily="34" charset="-120"/>
               </a:rPr>
-              <a:t>Giữ</a:t>
+              <a:t> nginx</a:t>
+            </a:r>
+            <a:r>
+              <a:rPr lang="en-US" sz="2250" dirty="0" spc="5" kern="0">
+                <a:solidFill>
+                  <a:srgbClr val="14161C"/>
+                </a:solidFill>
+                <a:latin typeface="Be Vietnam Pro" pitchFamily="34" charset="0"/>
+                <a:ea typeface="Be Vietnam Pro" pitchFamily="34" charset="-122"/>
+                <a:cs typeface="Be Vietnam Pro" pitchFamily="34" charset="-120"/>
+              </a:rPr>
+              <a:t> có</a:t>
+            </a:r>
+            <a:r>
+              <a:rPr lang="en-US" sz="2250" dirty="0" spc="-9" kern="0">
+                <a:solidFill>
+                  <a:srgbClr val="14161C"/>
+                </a:solidFill>
+                <a:latin typeface="Be Vietnam Pro" pitchFamily="34" charset="0"/>
+                <a:ea typeface="Be Vietnam Pro" pitchFamily="34" charset="-122"/>
+                <a:cs typeface="Be Vietnam Pro" pitchFamily="34" charset="-120"/>
+              </a:rPr>
+              <a:t> consistent</a:t>
+            </a:r>
+            <a:r>
+              <a:rPr lang="en-US" sz="2250" dirty="0" spc="14" kern="0">
+                <a:solidFill>
+                  <a:srgbClr val="14161C"/>
+                </a:solidFill>
+                <a:latin typeface="Be Vietnam Pro" pitchFamily="34" charset="0"/>
+                <a:ea typeface="Be Vietnam Pro" pitchFamily="34" charset="-122"/>
+                <a:cs typeface="Be Vietnam Pro" pitchFamily="34" charset="-120"/>
+              </a:rPr>
+              <a:t> để</a:t>
+            </a:r>
+            <a:r>
+              <a:rPr lang="en-US" sz="2250" dirty="0" spc="-11" kern="0">
+                <a:solidFill>
+                  <a:srgbClr val="14161C"/>
+                </a:solidFill>
+                <a:latin typeface="Be Vietnam Pro" pitchFamily="34" charset="0"/>
+                <a:ea typeface="Be Vietnam Pro" pitchFamily="34" charset="-122"/>
+                <a:cs typeface="Be Vietnam Pro" pitchFamily="34" charset="-120"/>
+              </a:rPr>
+              <a:t> chuyển</a:t>
             </a:r>
             <a:r>
               <a:rPr lang="en-US" sz="2250" dirty="0" spc="1" kern="0">
@@ -19819,117 +19951,18 @@
                 <a:ea typeface="Be Vietnam Pro" pitchFamily="34" charset="-122"/>
                 <a:cs typeface="Be Vietnam Pro" pitchFamily="34" charset="-120"/>
               </a:rPr>
-              <a:t> Alice</a:t>
-            </a:r>
-            <a:r>
-              <a:rPr lang="en-US" sz="2250" dirty="0" spc="5" kern="0">
-                <a:solidFill>
-                  <a:srgbClr val="14161C"/>
-                </a:solidFill>
-                <a:latin typeface="Be Vietnam Pro" pitchFamily="34" charset="0"/>
-                <a:ea typeface="Be Vietnam Pro" pitchFamily="34" charset="-122"/>
-                <a:cs typeface="Be Vietnam Pro" pitchFamily="34" charset="-120"/>
-              </a:rPr>
-              <a:t> ở</a:t>
-            </a:r>
-            <a:r>
-              <a:rPr lang="en-US" sz="2250" dirty="0" spc="2" kern="0">
-                <a:solidFill>
-                  <a:srgbClr val="14161C"/>
-                </a:solidFill>
-                <a:latin typeface="Be Vietnam Pro" pitchFamily="34" charset="0"/>
-                <a:ea typeface="Be Vietnam Pro" pitchFamily="34" charset="-122"/>
-                <a:cs typeface="Be Vietnam Pro" pitchFamily="34" charset="-120"/>
-              </a:rPr>
-              <a:t> dịch vụ</a:t>
-            </a:r>
-            <a:r>
-              <a:rPr lang="en-US" sz="2250" dirty="0" spc="-2" kern="0">
-                <a:solidFill>
-                  <a:srgbClr val="14161C"/>
-                </a:solidFill>
-                <a:latin typeface="Be Vietnam Pro" pitchFamily="34" charset="0"/>
-                <a:ea typeface="Be Vietnam Pro" pitchFamily="34" charset="-122"/>
-                <a:cs typeface="Be Vietnam Pro" pitchFamily="34" charset="-120"/>
-              </a:rPr>
-              <a:t> mà</a:t>
-            </a:r>
-            <a:r>
-              <a:rPr lang="en-US" sz="2250" dirty="0" spc="-20" kern="0">
-                <a:solidFill>
-                  <a:srgbClr val="14161C"/>
-                </a:solidFill>
-                <a:latin typeface="Be Vietnam Pro" pitchFamily="34" charset="0"/>
-                <a:ea typeface="Be Vietnam Pro" pitchFamily="34" charset="-122"/>
-                <a:cs typeface="Be Vietnam Pro" pitchFamily="34" charset="-120"/>
-              </a:rPr>
-              <a:t> yêu</a:t>
-            </a:r>
-            <a:r>
-              <a:rPr lang="en-US" sz="2250" dirty="0" spc="1" kern="0">
-                <a:solidFill>
-                  <a:srgbClr val="14161C"/>
-                </a:solidFill>
-                <a:latin typeface="Be Vietnam Pro" pitchFamily="34" charset="0"/>
-                <a:ea typeface="Be Vietnam Pro" pitchFamily="34" charset="-122"/>
-                <a:cs typeface="Be Vietnam Pro" pitchFamily="34" charset="-120"/>
-              </a:rPr>
-              <a:t> cầu</a:t>
-            </a:r>
-            <a:r>
-              <a:rPr lang="en-US" sz="2250" dirty="0" spc="11" kern="0">
-                <a:solidFill>
-                  <a:srgbClr val="14161C"/>
-                </a:solidFill>
-                <a:latin typeface="Be Vietnam Pro" pitchFamily="34" charset="0"/>
-                <a:ea typeface="Be Vietnam Pro" pitchFamily="34" charset="-122"/>
-                <a:cs typeface="Be Vietnam Pro" pitchFamily="34" charset="-120"/>
-              </a:rPr>
-              <a:t> đầu</a:t>
-            </a:r>
-            <a:r>
-              <a:rPr lang="en-US" sz="2250" dirty="0" spc="-1" kern="0">
-                <a:solidFill>
-                  <a:srgbClr val="14161C"/>
-                </a:solidFill>
-                <a:latin typeface="Be Vietnam Pro" pitchFamily="34" charset="0"/>
-                <a:ea typeface="Be Vietnam Pro" pitchFamily="34" charset="-122"/>
-                <a:cs typeface="Be Vietnam Pro" pitchFamily="34" charset="-120"/>
-              </a:rPr>
-              <a:t> tiên</a:t>
-            </a:r>
-            <a:r>
-              <a:rPr lang="en-US" sz="2250" dirty="0" spc="2" kern="0">
-                <a:solidFill>
-                  <a:srgbClr val="14161C"/>
-                </a:solidFill>
-                <a:latin typeface="Be Vietnam Pro" pitchFamily="34" charset="0"/>
-                <a:ea typeface="Be Vietnam Pro" pitchFamily="34" charset="-122"/>
-                <a:cs typeface="Be Vietnam Pro" pitchFamily="34" charset="-120"/>
-              </a:rPr>
-              <a:t> của</a:t>
-            </a:r>
-            <a:r>
-              <a:rPr lang="en-US" sz="2250" dirty="0" spc="1" kern="0">
-                <a:solidFill>
-                  <a:srgbClr val="14161C"/>
-                </a:solidFill>
-                <a:latin typeface="Be Vietnam Pro" pitchFamily="34" charset="0"/>
-                <a:ea typeface="Be Vietnam Pro" pitchFamily="34" charset="-122"/>
-                <a:cs typeface="Be Vietnam Pro" pitchFamily="34" charset="-120"/>
-              </a:rPr>
-              <a:t> Alice</a:t>
-            </a:r>
-            <a:r>
-              <a:rPr lang="en-US" sz="2250" dirty="0" spc="-7" kern="0">
-                <a:solidFill>
-                  <a:srgbClr val="14161C"/>
-                </a:solidFill>
-                <a:latin typeface="Be Vietnam Pro" pitchFamily="34" charset="0"/>
-                <a:ea typeface="Be Vietnam Pro" pitchFamily="34" charset="-122"/>
-                <a:cs typeface="Be Vietnam Pro" pitchFamily="34" charset="-120"/>
-              </a:rPr>
-              <a:t> tới.</a:t>
+              <a:t> ít</a:t>
+            </a:r>
+            <a:r>
+              <a:rPr lang="en-US" sz="2250" dirty="0" spc="0" kern="0">
+                <a:solidFill>
+                  <a:srgbClr val="14161C"/>
+                </a:solidFill>
+                <a:latin typeface="Be Vietnam Pro" pitchFamily="34" charset="0"/>
+                <a:ea typeface="Be Vietnam Pro" pitchFamily="34" charset="-122"/>
+                <a:cs typeface="Be Vietnam Pro" pitchFamily="34" charset="-120"/>
+              </a:rPr>
+              <a:t> khóa.</a:t>
             </a:r>
             <a:endParaRPr lang="en-US" sz="2250" dirty="0"/>
           </a:p>
@@ -21446,7 +21479,7 @@
               <a:buNone/>
             </a:pPr>
             <a:r>
-              <a:rPr lang="en-US" sz="2250" dirty="0" spc="-1" kern="0">
+              <a:rPr lang="en-US" sz="2250" dirty="0" spc="-4" kern="0">
                 <a:solidFill>
                   <a:srgbClr val="C4C8D6"/>
                 </a:solidFill>
@@ -21454,10 +21487,10 @@
                 <a:ea typeface="Be Vietnam Pro" pitchFamily="34" charset="-122"/>
                 <a:cs typeface="Be Vietnam Pro" pitchFamily="34" charset="-120"/>
               </a:rPr>
-              <a:t>Sáu</a:t>
-            </a:r>
-            <a:r>
-              <a:rPr lang="en-US" sz="2250" dirty="0" spc="-8" kern="0">
+              <a:t>Chỉ</a:t>
+            </a:r>
+            <a:r>
+              <a:rPr lang="en-US" sz="2250" dirty="0" spc="-9" kern="0">
                 <a:solidFill>
                   <a:srgbClr val="C4C8D6"/>
                 </a:solidFill>
@@ -21465,10 +21498,10 @@
                 <a:ea typeface="Be Vietnam Pro" pitchFamily="34" charset="-122"/>
                 <a:cs typeface="Be Vietnam Pro" pitchFamily="34" charset="-120"/>
               </a:rPr>
-              <a:t> thuật</a:t>
-            </a:r>
-            <a:r>
-              <a:rPr lang="en-US" sz="2250" dirty="0" spc="-11" kern="0">
+              <a:t> lấy</a:t>
+            </a:r>
+            <a:r>
+              <a:rPr lang="en-US" sz="2250" dirty="0" spc="-5" kern="0">
                 <a:solidFill>
                   <a:srgbClr val="C4C8D6"/>
                 </a:solidFill>
@@ -21476,7 +21509,29 @@
                 <a:ea typeface="Be Vietnam Pro" pitchFamily="34" charset="-122"/>
                 <a:cs typeface="Be Vietnam Pro" pitchFamily="34" charset="-120"/>
               </a:rPr>
-              <a:t> toán,</a:t>
+              <a:t> sáu</a:t>
+            </a:r>
+            <a:r>
+              <a:rPr lang="en-US" sz="2250" dirty="0" spc="-10" kern="0">
+                <a:solidFill>
+                  <a:srgbClr val="C4C8D6"/>
+                </a:solidFill>
+                <a:latin typeface="Be Vietnam Pro" pitchFamily="34" charset="0"/>
+                <a:ea typeface="Be Vietnam Pro" pitchFamily="34" charset="-122"/>
+                <a:cs typeface="Be Vietnam Pro" pitchFamily="34" charset="-120"/>
+              </a:rPr>
+              <a:t> tên</a:t>
+            </a:r>
+            <a:r>
+              <a:rPr lang="en-US" sz="2250" dirty="0" spc="-17" kern="0">
+                <a:solidFill>
+                  <a:srgbClr val="C4C8D6"/>
+                </a:solidFill>
+                <a:latin typeface="Be Vietnam Pro" pitchFamily="34" charset="0"/>
+                <a:ea typeface="Be Vietnam Pro" pitchFamily="34" charset="-122"/>
+                <a:cs typeface="Be Vietnam Pro" pitchFamily="34" charset="-120"/>
+              </a:rPr>
+              <a:t> và</a:t>
             </a:r>
             <a:r>
               <a:rPr lang="en-US" sz="2250" dirty="0" spc="-2" kern="0">
@@ -21490,7 +21545,7 @@
               <a:t> hai</a:t>
             </a:r>
             <a:r>
-              <a:rPr lang="en-US" sz="2250" dirty="0" spc="2" kern="0">
+              <a:rPr lang="en-US" sz="2250" dirty="0" spc="1" kern="0">
                 <a:solidFill>
                   <a:srgbClr val="C4C8D6"/>
                 </a:solidFill>
@@ -21498,7 +21553,7 @@
                 <a:ea typeface="Be Vietnam Pro" pitchFamily="34" charset="-122"/>
                 <a:cs typeface="Be Vietnam Pro" pitchFamily="34" charset="-120"/>
               </a:rPr>
-              <a:t> nhóm.</a:t>
+              <a:t> nhãn.</a:t>
             </a:r>
             <a:endParaRPr lang="en-US" sz="2250" dirty="0"/>
           </a:p>
@@ -21583,6 +21638,28 @@
               </a:rPr>
               <a:t>NGINX</a:t>
             </a:r>
+            <a:r>
+              <a:rPr lang="en-US" sz="1800" b="1" spc="179" kern="0" dirty="0">
+                <a:solidFill>
+                  <a:srgbClr val="3DD6A0"/>
+                </a:solidFill>
+                <a:latin typeface="Be Vietnam Pro" pitchFamily="34" charset="0"/>
+                <a:ea typeface="Be Vietnam Pro" pitchFamily="34" charset="-122"/>
+                <a:cs typeface="Be Vietnam Pro" pitchFamily="34" charset="-120"/>
+              </a:rPr>
+              <a:t> VÀ</a:t>
+            </a:r>
+            <a:r>
+              <a:rPr lang="en-US" sz="1800" b="1" spc="208" kern="0" dirty="0">
+                <a:solidFill>
+                  <a:srgbClr val="3DD6A0"/>
+                </a:solidFill>
+                <a:latin typeface="Be Vietnam Pro" pitchFamily="34" charset="0"/>
+                <a:ea typeface="Be Vietnam Pro" pitchFamily="34" charset="-122"/>
+                <a:cs typeface="Be Vietnam Pro" pitchFamily="34" charset="-120"/>
+              </a:rPr>
+              <a:t> HAPROXY</a:t>
+            </a:r>
             <a:endParaRPr lang="en-US" sz="1800" dirty="0"/>
           </a:p>
         </p:txBody>
@@ -21634,17 +21711,6 @@
               <a:t> liệu</a:t>
             </a:r>
             <a:r>
-              <a:rPr lang="en-US" sz="2700" b="1" dirty="0" spc="-3" kern="0">
-                <a:solidFill>
-                  <a:srgbClr val="F3EEE3"/>
-                </a:solidFill>
-                <a:latin typeface="Be Vietnam Pro" pitchFamily="34" charset="0"/>
-                <a:ea typeface="Be Vietnam Pro" pitchFamily="34" charset="-122"/>
-                <a:cs typeface="Be Vietnam Pro" pitchFamily="34" charset="-120"/>
-              </a:rPr>
-              <a:t> mô-đun</a:t>
-            </a:r>
-            <a:r>
               <a:rPr lang="en-US" sz="2700" b="1" dirty="0" spc="-11" kern="0">
                 <a:solidFill>
                   <a:srgbClr val="F3EEE3"/>
@@ -21654,6 +21720,28 @@
                 <a:cs typeface="Be Vietnam Pro" pitchFamily="34" charset="-120"/>
               </a:rPr>
               <a:t> upstream</a:t>
+            </a:r>
+            <a:r>
+              <a:rPr lang="en-US" sz="2700" b="1" dirty="0" spc="-23" kern="0">
+                <a:solidFill>
+                  <a:srgbClr val="F3EEE3"/>
+                </a:solidFill>
+                <a:latin typeface="Be Vietnam Pro" pitchFamily="34" charset="0"/>
+                <a:ea typeface="Be Vietnam Pro" pitchFamily="34" charset="-122"/>
+                <a:cs typeface="Be Vietnam Pro" pitchFamily="34" charset="-120"/>
+              </a:rPr>
+              <a:t> và</a:t>
+            </a:r>
+            <a:r>
+              <a:rPr lang="en-US" sz="2700" b="1" dirty="0" spc="-4" kern="0">
+                <a:solidFill>
+                  <a:srgbClr val="F3EEE3"/>
+                </a:solidFill>
+                <a:latin typeface="Be Vietnam Pro" pitchFamily="34" charset="0"/>
+                <a:ea typeface="Be Vietnam Pro" pitchFamily="34" charset="-122"/>
+                <a:cs typeface="Be Vietnam Pro" pitchFamily="34" charset="-120"/>
+              </a:rPr>
+              <a:t> balance</a:t>
             </a:r>
             <a:endParaRPr lang="en-US" sz="2700" dirty="0"/>
           </a:p>
@@ -21687,7 +21775,7 @@
               <a:buNone/>
             </a:pPr>
             <a:r>
-              <a:rPr lang="en-US" sz="2250" dirty="0" spc="-2" kern="0">
+              <a:rPr lang="en-US" sz="2250" dirty="0" spc="-1" kern="0">
                 <a:solidFill>
                   <a:srgbClr val="C4C8D6"/>
                 </a:solidFill>
@@ -21695,10 +21783,10 @@
                 <a:ea typeface="Be Vietnam Pro" pitchFamily="34" charset="-122"/>
                 <a:cs typeface="Be Vietnam Pro" pitchFamily="34" charset="-120"/>
               </a:rPr>
-              <a:t>Mặc</a:t>
-            </a:r>
-            <a:r>
-              <a:rPr lang="en-US" sz="2250" dirty="0" spc="19" kern="0">
+              <a:t>nginx:</a:t>
+            </a:r>
+            <a:r>
+              <a:rPr lang="en-US" sz="2250" dirty="0" spc="-17" kern="0">
                 <a:solidFill>
                   <a:srgbClr val="C4C8D6"/>
                 </a:solidFill>
@@ -21706,7 +21794,40 @@
                 <a:ea typeface="Be Vietnam Pro" pitchFamily="34" charset="-122"/>
                 <a:cs typeface="Be Vietnam Pro" pitchFamily="34" charset="-120"/>
               </a:rPr>
-              <a:t> định</a:t>
+              <a:t> weighted</a:t>
+            </a:r>
+            <a:r>
+              <a:rPr lang="en-US" sz="2250" dirty="0" spc="-15" kern="0">
+                <a:solidFill>
+                  <a:srgbClr val="C4C8D6"/>
+                </a:solidFill>
+                <a:latin typeface="Be Vietnam Pro" pitchFamily="34" charset="0"/>
+                <a:ea typeface="Be Vietnam Pro" pitchFamily="34" charset="-122"/>
+                <a:cs typeface="Be Vietnam Pro" pitchFamily="34" charset="-120"/>
+              </a:rPr>
+              <a:t> round-robin,</a:t>
+            </a:r>
+            <a:r>
+              <a:rPr lang="en-US" sz="2250" dirty="0" spc="0" kern="0">
+                <a:solidFill>
+                  <a:srgbClr val="C4C8D6"/>
+                </a:solidFill>
+                <a:latin typeface="Be Vietnam Pro" pitchFamily="34" charset="0"/>
+                <a:ea typeface="Be Vietnam Pro" pitchFamily="34" charset="-122"/>
+                <a:cs typeface="Be Vietnam Pro" pitchFamily="34" charset="-120"/>
+              </a:rPr>
+              <a:t> hash,</a:t>
+            </a:r>
+            <a:r>
+              <a:rPr lang="en-US" sz="2250" dirty="0" spc="-3" kern="0">
+                <a:solidFill>
+                  <a:srgbClr val="C4C8D6"/>
+                </a:solidFill>
+                <a:latin typeface="Be Vietnam Pro" pitchFamily="34" charset="0"/>
+                <a:ea typeface="Be Vietnam Pro" pitchFamily="34" charset="-122"/>
+                <a:cs typeface="Be Vietnam Pro" pitchFamily="34" charset="-120"/>
+              </a:rPr>
+              <a:t> least_conn;</a:t>
             </a:r>
             <a:r>
               <a:rPr lang="en-US" sz="2250" dirty="0" spc="-18" kern="0">
@@ -21717,10 +21838,10 @@
                 <a:ea typeface="Be Vietnam Pro" pitchFamily="34" charset="-122"/>
                 <a:cs typeface="Be Vietnam Pro" pitchFamily="34" charset="-120"/>
               </a:rPr>
-              <a:t> weighted</a:t>
-            </a:r>
-            <a:r>
-              <a:rPr lang="en-US" sz="2250" dirty="0" spc="-14" kern="0">
+              <a:t> HAProxy:</a:t>
+            </a:r>
+            <a:r>
+              <a:rPr lang="en-US" sz="2250" dirty="0" spc="-7" kern="0">
                 <a:solidFill>
                   <a:srgbClr val="C4C8D6"/>
                 </a:solidFill>
@@ -21728,10 +21849,10 @@
                 <a:ea typeface="Be Vietnam Pro" pitchFamily="34" charset="-122"/>
                 <a:cs typeface="Be Vietnam Pro" pitchFamily="34" charset="-120"/>
               </a:rPr>
-              <a:t> round-robin,</a:t>
-            </a:r>
-            <a:r>
-              <a:rPr lang="en-US" sz="2250" dirty="0" spc="-1" kern="0">
+              <a:t> leastconn,</a:t>
+            </a:r>
+            <a:r>
+              <a:rPr lang="en-US" sz="2250" dirty="0" spc="1" kern="0">
                 <a:solidFill>
                   <a:srgbClr val="C4C8D6"/>
                 </a:solidFill>
@@ -21739,10 +21860,10 @@
                 <a:ea typeface="Be Vietnam Pro" pitchFamily="34" charset="-122"/>
                 <a:cs typeface="Be Vietnam Pro" pitchFamily="34" charset="-120"/>
               </a:rPr>
-              <a:t> ip_hash,</a:t>
-            </a:r>
-            <a:r>
-              <a:rPr lang="en-US" sz="2250" dirty="0" spc="0" kern="0">
+              <a:t> tĩnh</a:t>
+            </a:r>
+            <a:r>
+              <a:rPr lang="en-US" sz="2250" dirty="0" spc="-17" kern="0">
                 <a:solidFill>
                   <a:srgbClr val="C4C8D6"/>
                 </a:solidFill>
@@ -21750,10 +21871,10 @@
                 <a:ea typeface="Be Vietnam Pro" pitchFamily="34" charset="-122"/>
                 <a:cs typeface="Be Vietnam Pro" pitchFamily="34" charset="-120"/>
               </a:rPr>
-              <a:t> hash,</a:t>
-            </a:r>
-            <a:r>
-              <a:rPr lang="en-US" sz="2250" dirty="0" spc="-2" kern="0">
+              <a:t> và</a:t>
+            </a:r>
+            <a:r>
+              <a:rPr lang="en-US" sz="2250" dirty="0" spc="10" kern="0">
                 <a:solidFill>
                   <a:srgbClr val="C4C8D6"/>
                 </a:solidFill>
@@ -21761,18 +21882,7 @@
                 <a:ea typeface="Be Vietnam Pro" pitchFamily="34" charset="-122"/>
                 <a:cs typeface="Be Vietnam Pro" pitchFamily="34" charset="-120"/>
               </a:rPr>
-              <a:t> least_conn,</a:t>
-            </a:r>
-            <a:r>
-              <a:rPr lang="en-US" sz="2250" dirty="0" spc="-3" kern="0">
-                <a:solidFill>
-                  <a:srgbClr val="C4C8D6"/>
-                </a:solidFill>
-                <a:latin typeface="Be Vietnam Pro" pitchFamily="34" charset="0"/>
-                <a:ea typeface="Be Vietnam Pro" pitchFamily="34" charset="-122"/>
-                <a:cs typeface="Be Vietnam Pro" pitchFamily="34" charset="-120"/>
-              </a:rPr>
-              <a:t> sticky, least_time.</a:t>
+              <a:t> động.</a:t>
             </a:r>
             <a:endParaRPr lang="en-US" sz="2250" dirty="0"/>
           </a:p>
@@ -21925,6 +22035,28 @@
               <a:t> ngày</a:t>
             </a:r>
             <a:r>
+              <a:rPr lang="en-US" sz="2550" dirty="0" spc="-2" kern="0">
+                <a:solidFill>
+                  <a:srgbClr val="F3EEE3"/>
+                </a:solidFill>
+                <a:latin typeface="Be Vietnam Pro" pitchFamily="34" charset="0"/>
+                <a:ea typeface="Be Vietnam Pro" pitchFamily="34" charset="-122"/>
+                <a:cs typeface="Be Vietnam Pro" pitchFamily="34" charset="-120"/>
+              </a:rPr>
+              <a:t> 2026-10-19.</a:t>
+            </a:r>
+            <a:r>
+              <a:rPr lang="en-US" sz="2550" dirty="0" spc="0" kern="0">
+                <a:solidFill>
+                  <a:srgbClr val="F3EEE3"/>
+                </a:solidFill>
+                <a:latin typeface="Be Vietnam Pro" pitchFamily="34" charset="0"/>
+                <a:ea typeface="Be Vietnam Pro" pitchFamily="34" charset="-122"/>
+                <a:cs typeface="Be Vietnam Pro" pitchFamily="34" charset="-120"/>
+              </a:rPr>
+              <a:t> Hình</a:t>
+            </a:r>
+            <a:r>
               <a:rPr lang="en-US" sz="2550" dirty="0" spc="-1" kern="0">
                 <a:solidFill>
                   <a:srgbClr val="F3EEE3"/>
@@ -21933,10 +22065,10 @@
                 <a:ea typeface="Be Vietnam Pro" pitchFamily="34" charset="-122"/>
                 <a:cs typeface="Be Vietnam Pro" pitchFamily="34" charset="-120"/>
               </a:rPr>
-              <a:t> 2026-10-18. Hình minh</a:t>
-            </a:r>
-            <a:r>
-              <a:rPr lang="en-US" sz="2550" dirty="0" spc="-3" kern="0">
+              <a:t> minh</a:t>
+            </a:r>
+            <a:r>
+              <a:rPr lang="en-US" sz="2550" dirty="0" spc="-4" kern="0">
                 <a:solidFill>
                   <a:srgbClr val="F3EEE3"/>
                 </a:solidFill>
@@ -21947,7 +22079,7 @@
               <a:t> họa</a:t>
             </a:r>
             <a:r>
-              <a:rPr lang="en-US" sz="2550" dirty="0" spc="0" kern="0">
+              <a:rPr lang="en-US" sz="2550" dirty="0" spc="1" kern="0">
                 <a:solidFill>
                   <a:srgbClr val="F3EEE3"/>
                 </a:solidFill>

</xml_diff>

<commit_message>
Lessons sd-10-018, 020, 021: say ip_hash has no consistent parameter, call List an interface, and record which added claims were checked against project docs, with the decks
Co-Authored-By: Claude Sonnet 5.5 <noreply@anthropic.com>
Claude-Session: https://claude.ai/code/session_011dmt3ZFdN8sjiTfDnyUVN7
</commit_message>
<xml_diff>
--- a/system-design-101/vi/lessons/sd-10-018/slides/sd-10-018.pptx
+++ b/system-design-101/vi/lessons/sd-10-018/slides/sd-10-018.pptx
@@ -19888,18 +19888,18 @@
               <a:t> máy;</a:t>
             </a:r>
             <a:r>
-              <a:rPr lang="en-US" sz="2250" dirty="0" spc="-1" kern="0">
-                <a:solidFill>
-                  <a:srgbClr val="14161C"/>
-                </a:solidFill>
-                <a:latin typeface="Be Vietnam Pro" pitchFamily="34" charset="0"/>
-                <a:ea typeface="Be Vietnam Pro" pitchFamily="34" charset="-122"/>
-                <a:cs typeface="Be Vietnam Pro" pitchFamily="34" charset="-120"/>
-              </a:rPr>
-              <a:t> nginx</a:t>
-            </a:r>
-            <a:r>
-              <a:rPr lang="en-US" sz="2250" dirty="0" spc="5" kern="0">
+              <a:rPr lang="en-US" sz="2250" dirty="0" spc="1" kern="0">
+                <a:solidFill>
+                  <a:srgbClr val="14161C"/>
+                </a:solidFill>
+                <a:latin typeface="Be Vietnam Pro" pitchFamily="34" charset="0"/>
+                <a:ea typeface="Be Vietnam Pro" pitchFamily="34" charset="-122"/>
+                <a:cs typeface="Be Vietnam Pro" pitchFamily="34" charset="-120"/>
+              </a:rPr>
+              <a:t> chỉ hash</a:t>
+            </a:r>
+            <a:r>
+              <a:rPr lang="en-US" sz="2250" dirty="0" spc="4" kern="0">
                 <a:solidFill>
                   <a:srgbClr val="14161C"/>
                 </a:solidFill>
@@ -19918,29 +19918,7 @@
                 <a:ea typeface="Be Vietnam Pro" pitchFamily="34" charset="-122"/>
                 <a:cs typeface="Be Vietnam Pro" pitchFamily="34" charset="-120"/>
               </a:rPr>
-              <a:t> consistent</a:t>
-            </a:r>
-            <a:r>
-              <a:rPr lang="en-US" sz="2250" dirty="0" spc="14" kern="0">
-                <a:solidFill>
-                  <a:srgbClr val="14161C"/>
-                </a:solidFill>
-                <a:latin typeface="Be Vietnam Pro" pitchFamily="34" charset="0"/>
-                <a:ea typeface="Be Vietnam Pro" pitchFamily="34" charset="-122"/>
-                <a:cs typeface="Be Vietnam Pro" pitchFamily="34" charset="-120"/>
-              </a:rPr>
-              <a:t> để</a:t>
-            </a:r>
-            <a:r>
-              <a:rPr lang="en-US" sz="2250" dirty="0" spc="-11" kern="0">
-                <a:solidFill>
-                  <a:srgbClr val="14161C"/>
-                </a:solidFill>
-                <a:latin typeface="Be Vietnam Pro" pitchFamily="34" charset="0"/>
-                <a:ea typeface="Be Vietnam Pro" pitchFamily="34" charset="-122"/>
-                <a:cs typeface="Be Vietnam Pro" pitchFamily="34" charset="-120"/>
-              </a:rPr>
-              <a:t> chuyển</a:t>
+              <a:t> consistent,</a:t>
             </a:r>
             <a:r>
               <a:rPr lang="en-US" sz="2250" dirty="0" spc="1" kern="0">
@@ -19951,7 +19929,7 @@
                 <a:ea typeface="Be Vietnam Pro" pitchFamily="34" charset="-122"/>
                 <a:cs typeface="Be Vietnam Pro" pitchFamily="34" charset="-120"/>
               </a:rPr>
-              <a:t> ít</a:t>
+              <a:t> ip_hash</a:t>
             </a:r>
             <a:r>
               <a:rPr lang="en-US" sz="2250" dirty="0" spc="0" kern="0">
@@ -19962,7 +19940,18 @@
                 <a:ea typeface="Be Vietnam Pro" pitchFamily="34" charset="-122"/>
                 <a:cs typeface="Be Vietnam Pro" pitchFamily="34" charset="-120"/>
               </a:rPr>
-              <a:t> khóa.</a:t>
+              <a:t> thì</a:t>
+            </a:r>
+            <a:r>
+              <a:rPr lang="en-US" sz="2250" dirty="0" spc="2" kern="0">
+                <a:solidFill>
+                  <a:srgbClr val="14161C"/>
+                </a:solidFill>
+                <a:latin typeface="Be Vietnam Pro" pitchFamily="34" charset="0"/>
+                <a:ea typeface="Be Vietnam Pro" pitchFamily="34" charset="-122"/>
+                <a:cs typeface="Be Vietnam Pro" pitchFamily="34" charset="-120"/>
+              </a:rPr>
+              <a:t> không.</a:t>
             </a:r>
             <a:endParaRPr lang="en-US" sz="2250" dirty="0"/>
           </a:p>

</xml_diff>

<commit_message>
Lessons sd-10-018, 021: include active connections in the least-time card and remove the nonexistent abbreviation exception from the editorial note, with the figure, alt text and deck
Co-Authored-By: Claude Sonnet 5.5 <noreply@anthropic.com>
Claude-Session: https://claude.ai/code/session_011dmt3ZFdN8sjiTfDnyUVN7
</commit_message>
<xml_diff>
--- a/system-design-101/vi/lessons/sd-10-018/slides/sd-10-018.pptx
+++ b/system-design-101/vi/lessons/sd-10-018/slides/sd-10-018.pptx
@@ -15741,26 +15741,48 @@
               <a:t> hồi</a:t>
             </a:r>
             <a:r>
-              <a:rPr lang="en-US" sz="1950" dirty="0" spc="-6" kern="0">
-                <a:solidFill>
-                  <a:srgbClr val="14161C"/>
-                </a:solidFill>
-                <a:latin typeface="Be Vietnam Pro" pitchFamily="34" charset="0"/>
-                <a:ea typeface="Be Vietnam Pro" pitchFamily="34" charset="-122"/>
-                <a:cs typeface="Be Vietnam Pro" pitchFamily="34" charset="-120"/>
-              </a:rPr>
-              <a:t> ngắn</a:t>
-            </a:r>
-            <a:r>
-              <a:rPr lang="en-US" sz="1950" dirty="0" spc="-8" kern="0">
-                <a:solidFill>
-                  <a:srgbClr val="14161C"/>
-                </a:solidFill>
-                <a:latin typeface="Be Vietnam Pro" pitchFamily="34" charset="0"/>
-                <a:ea typeface="Be Vietnam Pro" pitchFamily="34" charset="-122"/>
-                <a:cs typeface="Be Vietnam Pro" pitchFamily="34" charset="-120"/>
-              </a:rPr>
-              <a:t> nhất</a:t>
+              <a:rPr lang="en-US" sz="1950" dirty="0" spc="-4" kern="0">
+                <a:solidFill>
+                  <a:srgbClr val="14161C"/>
+                </a:solidFill>
+                <a:latin typeface="Be Vietnam Pro" pitchFamily="34" charset="0"/>
+                <a:ea typeface="Be Vietnam Pro" pitchFamily="34" charset="-122"/>
+                <a:cs typeface="Be Vietnam Pro" pitchFamily="34" charset="-120"/>
+              </a:rPr>
+              <a:t> ngắn,</a:t>
+            </a:r>
+            <a:r>
+              <a:rPr lang="en-US" sz="1950" dirty="0" spc="-2" kern="0">
+                <a:solidFill>
+                  <a:srgbClr val="14161C"/>
+                </a:solidFill>
+                <a:latin typeface="Be Vietnam Pro" pitchFamily="34" charset="0"/>
+                <a:ea typeface="Be Vietnam Pro" pitchFamily="34" charset="-122"/>
+                <a:cs typeface="Be Vietnam Pro" pitchFamily="34" charset="-120"/>
+              </a:rPr>
+              <a:t> ít</a:t>
+            </a:r>
+            <a:r>
+              <a:rPr lang="en-US" sz="1950" dirty="0" spc="-29" kern="0">
+                <a:solidFill>
+                  <a:srgbClr val="14161C"/>
+                </a:solidFill>
+                <a:latin typeface="Be Vietnam Pro" pitchFamily="34" charset="0"/>
+                <a:ea typeface="Be Vietnam Pro" pitchFamily="34" charset="-122"/>
+                <a:cs typeface="Be Vietnam Pro" pitchFamily="34" charset="-120"/>
+              </a:rPr>
+              <a:t> kết</a:t>
+            </a:r>
+            <a:r>
+              <a:rPr lang="en-US" sz="1950" dirty="0" spc="0" kern="0">
+                <a:solidFill>
+                  <a:srgbClr val="14161C"/>
+                </a:solidFill>
+                <a:latin typeface="Be Vietnam Pro" pitchFamily="34" charset="0"/>
+                <a:ea typeface="Be Vietnam Pro" pitchFamily="34" charset="-122"/>
+                <a:cs typeface="Be Vietnam Pro" pitchFamily="34" charset="-120"/>
+              </a:rPr>
+              <a:t> nối</a:t>
             </a:r>
             <a:endParaRPr lang="en-US" sz="1950" dirty="0"/>
           </a:p>

</xml_diff>

<commit_message>
Lesson sd-10-018: show both selection factors of least response time on the deck's dynamic algorithms slide
Co-Authored-By: Claude Sonnet 5.5 <noreply@anthropic.com>
Claude-Session: https://claude.ai/code/session_011dmt3ZFdN8sjiTfDnyUVN7
</commit_message>
<xml_diff>
--- a/system-design-101/vi/lessons/sd-10-018/slides/sd-10-018.pptx
+++ b/system-design-101/vi/lessons/sd-10-018/slides/sd-10-018.pptx
@@ -10595,26 +10595,59 @@
               <a:buNone/>
             </a:pPr>
             <a:r>
-              <a:rPr lang="en-US" sz="2700" dirty="0" spc="-92" kern="0">
-                <a:solidFill>
-                  <a:srgbClr val="F3EEE3"/>
-                </a:solidFill>
-                <a:latin typeface="Be Vietnam Pro" pitchFamily="34" charset="0"/>
-                <a:ea typeface="Be Vietnam Pro" pitchFamily="34" charset="-122"/>
-                <a:cs typeface="Be Vietnam Pro" pitchFamily="34" charset="-120"/>
-              </a:rPr>
-              <a:t>Yêu</a:t>
-            </a:r>
-            <a:r>
-              <a:rPr lang="en-US" sz="2700" dirty="0" spc="1" kern="0">
-                <a:solidFill>
-                  <a:srgbClr val="F3EEE3"/>
-                </a:solidFill>
-                <a:latin typeface="Be Vietnam Pro" pitchFamily="34" charset="0"/>
-                <a:ea typeface="Be Vietnam Pro" pitchFamily="34" charset="-122"/>
-                <a:cs typeface="Be Vietnam Pro" pitchFamily="34" charset="-120"/>
-              </a:rPr>
-              <a:t> cầu</a:t>
+              <a:rPr lang="en-US" sz="2700" dirty="0" spc="3" kern="0">
+                <a:solidFill>
+                  <a:srgbClr val="F3EEE3"/>
+                </a:solidFill>
+                <a:latin typeface="Be Vietnam Pro" pitchFamily="34" charset="0"/>
+                <a:ea typeface="Be Vietnam Pro" pitchFamily="34" charset="-122"/>
+                <a:cs typeface="Be Vietnam Pro" pitchFamily="34" charset="-120"/>
+              </a:rPr>
+              <a:t>Ít</a:t>
+            </a:r>
+            <a:r>
+              <a:rPr lang="en-US" sz="2700" dirty="0" spc="-38" kern="0">
+                <a:solidFill>
+                  <a:srgbClr val="F3EEE3"/>
+                </a:solidFill>
+                <a:latin typeface="Be Vietnam Pro" pitchFamily="34" charset="0"/>
+                <a:ea typeface="Be Vietnam Pro" pitchFamily="34" charset="-122"/>
+                <a:cs typeface="Be Vietnam Pro" pitchFamily="34" charset="-120"/>
+              </a:rPr>
+              <a:t> kết</a:t>
+            </a:r>
+            <a:r>
+              <a:rPr lang="en-US" sz="2700" dirty="0" spc="-3" kern="0">
+                <a:solidFill>
+                  <a:srgbClr val="F3EEE3"/>
+                </a:solidFill>
+                <a:latin typeface="Be Vietnam Pro" pitchFamily="34" charset="0"/>
+                <a:ea typeface="Be Vietnam Pro" pitchFamily="34" charset="-122"/>
+                <a:cs typeface="Be Vietnam Pro" pitchFamily="34" charset="-120"/>
+              </a:rPr>
+              <a:t> nối</a:t>
+            </a:r>
+            <a:r>
+              <a:rPr lang="en-US" sz="2700" dirty="0" spc="-8" kern="0">
+                <a:solidFill>
+                  <a:srgbClr val="F3EEE3"/>
+                </a:solidFill>
+                <a:latin typeface="Be Vietnam Pro" pitchFamily="34" charset="0"/>
+                <a:ea typeface="Be Vietnam Pro" pitchFamily="34" charset="-122"/>
+                <a:cs typeface="Be Vietnam Pro" pitchFamily="34" charset="-120"/>
+              </a:rPr>
+              <a:t> nhất;</a:t>
+            </a:r>
+            <a:r>
+              <a:rPr lang="en-US" sz="2700" dirty="0" spc="-3" kern="0">
+                <a:solidFill>
+                  <a:srgbClr val="F3EEE3"/>
+                </a:solidFill>
+                <a:latin typeface="Be Vietnam Pro" pitchFamily="34" charset="0"/>
+                <a:ea typeface="Be Vietnam Pro" pitchFamily="34" charset="-122"/>
+                <a:cs typeface="Be Vietnam Pro" pitchFamily="34" charset="-120"/>
+              </a:rPr>
+              <a:t> hoặc</a:t>
             </a:r>
             <a:r>
               <a:rPr lang="en-US" sz="2700" dirty="0" spc="-2" kern="0">
@@ -10625,131 +10658,76 @@
                 <a:ea typeface="Be Vietnam Pro" pitchFamily="34" charset="-122"/>
                 <a:cs typeface="Be Vietnam Pro" pitchFamily="34" charset="-120"/>
               </a:rPr>
-              <a:t> mới</a:t>
-            </a:r>
-            <a:r>
-              <a:rPr lang="en-US" sz="2700" dirty="0" spc="-13" kern="0">
-                <a:solidFill>
-                  <a:srgbClr val="F3EEE3"/>
-                </a:solidFill>
-                <a:latin typeface="Be Vietnam Pro" pitchFamily="34" charset="0"/>
-                <a:ea typeface="Be Vietnam Pro" pitchFamily="34" charset="-122"/>
-                <a:cs typeface="Be Vietnam Pro" pitchFamily="34" charset="-120"/>
-              </a:rPr>
-              <a:t> tới</a:t>
-            </a:r>
-            <a:r>
-              <a:rPr lang="en-US" sz="2700" dirty="0" spc="-6" kern="0">
-                <a:solidFill>
-                  <a:srgbClr val="F3EEE3"/>
-                </a:solidFill>
-                <a:latin typeface="Be Vietnam Pro" pitchFamily="34" charset="0"/>
-                <a:ea typeface="Be Vietnam Pro" pitchFamily="34" charset="-122"/>
-                <a:cs typeface="Be Vietnam Pro" pitchFamily="34" charset="-120"/>
-              </a:rPr>
-              <a:t> bản</a:t>
+              <a:t> phản hồi</a:t>
+            </a:r>
+            <a:r>
+              <a:rPr lang="en-US" sz="2700" dirty="0" spc="-3" kern="0">
+                <a:solidFill>
+                  <a:srgbClr val="F3EEE3"/>
+                </a:solidFill>
+                <a:latin typeface="Be Vietnam Pro" pitchFamily="34" charset="0"/>
+                <a:ea typeface="Be Vietnam Pro" pitchFamily="34" charset="-122"/>
+                <a:cs typeface="Be Vietnam Pro" pitchFamily="34" charset="-120"/>
+              </a:rPr>
+              <a:t> nhanh</a:t>
+            </a:r>
+            <a:r>
+              <a:rPr lang="en-US" sz="2700" dirty="0" spc="-11" kern="0">
+                <a:solidFill>
+                  <a:srgbClr val="F3EEE3"/>
+                </a:solidFill>
+                <a:latin typeface="Be Vietnam Pro" pitchFamily="34" charset="0"/>
+                <a:ea typeface="Be Vietnam Pro" pitchFamily="34" charset="-122"/>
+                <a:cs typeface="Be Vietnam Pro" pitchFamily="34" charset="-120"/>
+              </a:rPr>
+              <a:t> nhất</a:t>
+            </a:r>
+            <a:r>
+              <a:rPr lang="en-US" sz="2700" dirty="0" spc="-17" kern="0">
+                <a:solidFill>
+                  <a:srgbClr val="F3EEE3"/>
+                </a:solidFill>
+                <a:latin typeface="Be Vietnam Pro" pitchFamily="34" charset="0"/>
+                <a:ea typeface="Be Vietnam Pro" pitchFamily="34" charset="-122"/>
+                <a:cs typeface="Be Vietnam Pro" pitchFamily="34" charset="-120"/>
+              </a:rPr>
+              <a:t> và</a:t>
+            </a:r>
+            <a:r>
+              <a:rPr lang="en-US" sz="2700" dirty="0" spc="-1" kern="0">
+                <a:solidFill>
+                  <a:srgbClr val="F3EEE3"/>
+                </a:solidFill>
+                <a:latin typeface="Be Vietnam Pro" pitchFamily="34" charset="0"/>
+                <a:ea typeface="Be Vietnam Pro" pitchFamily="34" charset="-122"/>
+                <a:cs typeface="Be Vietnam Pro" pitchFamily="34" charset="-120"/>
+              </a:rPr>
+              <a:t> ít</a:t>
+            </a:r>
+            <a:r>
+              <a:rPr lang="en-US" sz="2700" dirty="0" spc="-39" kern="0">
+                <a:solidFill>
+                  <a:srgbClr val="F3EEE3"/>
+                </a:solidFill>
+                <a:latin typeface="Be Vietnam Pro" pitchFamily="34" charset="0"/>
+                <a:ea typeface="Be Vietnam Pro" pitchFamily="34" charset="-122"/>
+                <a:cs typeface="Be Vietnam Pro" pitchFamily="34" charset="-120"/>
+              </a:rPr>
+              <a:t> kết</a:t>
+            </a:r>
+            <a:r>
+              <a:rPr lang="en-US" sz="2700" dirty="0" spc="-2" kern="0">
+                <a:solidFill>
+                  <a:srgbClr val="F3EEE3"/>
+                </a:solidFill>
+                <a:latin typeface="Be Vietnam Pro" pitchFamily="34" charset="0"/>
+                <a:ea typeface="Be Vietnam Pro" pitchFamily="34" charset="-122"/>
+                <a:cs typeface="Be Vietnam Pro" pitchFamily="34" charset="-120"/>
+              </a:rPr>
+              <a:t> nối</a:t>
             </a:r>
             <a:r>
               <a:rPr lang="en-US" sz="2700" dirty="0" spc="-10" kern="0">
-                <a:solidFill>
-                  <a:srgbClr val="F3EEE3"/>
-                </a:solidFill>
-                <a:latin typeface="Be Vietnam Pro" pitchFamily="34" charset="0"/>
-                <a:ea typeface="Be Vietnam Pro" pitchFamily="34" charset="-122"/>
-                <a:cs typeface="Be Vietnam Pro" pitchFamily="34" charset="-120"/>
-              </a:rPr>
-              <a:t> sao</a:t>
-            </a:r>
-            <a:r>
-              <a:rPr lang="en-US" sz="2700" dirty="0" spc="-1" kern="0">
-                <a:solidFill>
-                  <a:srgbClr val="F3EEE3"/>
-                </a:solidFill>
-                <a:latin typeface="Be Vietnam Pro" pitchFamily="34" charset="0"/>
-                <a:ea typeface="Be Vietnam Pro" pitchFamily="34" charset="-122"/>
-                <a:cs typeface="Be Vietnam Pro" pitchFamily="34" charset="-120"/>
-              </a:rPr>
-              <a:t> có</a:t>
-            </a:r>
-            <a:r>
-              <a:rPr lang="en-US" sz="2700" dirty="0" spc="-39" kern="0">
-                <a:solidFill>
-                  <a:srgbClr val="F3EEE3"/>
-                </a:solidFill>
-                <a:latin typeface="Be Vietnam Pro" pitchFamily="34" charset="0"/>
-                <a:ea typeface="Be Vietnam Pro" pitchFamily="34" charset="-122"/>
-                <a:cs typeface="Be Vietnam Pro" pitchFamily="34" charset="-120"/>
-              </a:rPr>
-              <a:t> kết</a:t>
-            </a:r>
-            <a:r>
-              <a:rPr lang="en-US" sz="2700" dirty="0" spc="-2" kern="0">
-                <a:solidFill>
-                  <a:srgbClr val="F3EEE3"/>
-                </a:solidFill>
-                <a:latin typeface="Be Vietnam Pro" pitchFamily="34" charset="0"/>
-                <a:ea typeface="Be Vietnam Pro" pitchFamily="34" charset="-122"/>
-                <a:cs typeface="Be Vietnam Pro" pitchFamily="34" charset="-120"/>
-              </a:rPr>
-              <a:t> nối</a:t>
-            </a:r>
-            <a:r>
-              <a:rPr lang="en-US" sz="2700" dirty="0" spc="-1" kern="0">
-                <a:solidFill>
-                  <a:srgbClr val="F3EEE3"/>
-                </a:solidFill>
-                <a:latin typeface="Be Vietnam Pro" pitchFamily="34" charset="0"/>
-                <a:ea typeface="Be Vietnam Pro" pitchFamily="34" charset="-122"/>
-                <a:cs typeface="Be Vietnam Pro" pitchFamily="34" charset="-120"/>
-              </a:rPr>
-              <a:t> ít</a:t>
-            </a:r>
-            <a:r>
-              <a:rPr lang="en-US" sz="2700" dirty="0" spc="-11" kern="0">
-                <a:solidFill>
-                  <a:srgbClr val="F3EEE3"/>
-                </a:solidFill>
-                <a:latin typeface="Be Vietnam Pro" pitchFamily="34" charset="0"/>
-                <a:ea typeface="Be Vietnam Pro" pitchFamily="34" charset="-122"/>
-                <a:cs typeface="Be Vietnam Pro" pitchFamily="34" charset="-120"/>
-              </a:rPr>
-              <a:t> nhất</a:t>
-            </a:r>
-            <a:r>
-              <a:rPr lang="en-US" sz="2700" dirty="0" spc="-3" kern="0">
-                <a:solidFill>
-                  <a:srgbClr val="F3EEE3"/>
-                </a:solidFill>
-                <a:latin typeface="Be Vietnam Pro" pitchFamily="34" charset="0"/>
-                <a:ea typeface="Be Vietnam Pro" pitchFamily="34" charset="-122"/>
-                <a:cs typeface="Be Vietnam Pro" pitchFamily="34" charset="-120"/>
-              </a:rPr>
-              <a:t> hoặc</a:t>
-            </a:r>
-            <a:r>
-              <a:rPr lang="en-US" sz="2700" dirty="0" spc="-2" kern="0">
-                <a:solidFill>
-                  <a:srgbClr val="F3EEE3"/>
-                </a:solidFill>
-                <a:latin typeface="Be Vietnam Pro" pitchFamily="34" charset="0"/>
-                <a:ea typeface="Be Vietnam Pro" pitchFamily="34" charset="-122"/>
-                <a:cs typeface="Be Vietnam Pro" pitchFamily="34" charset="-120"/>
-              </a:rPr>
-              <a:t> phản hồi</a:t>
-            </a:r>
-            <a:r>
-              <a:rPr lang="en-US" sz="2700" dirty="0" spc="-3" kern="0">
-                <a:solidFill>
-                  <a:srgbClr val="F3EEE3"/>
-                </a:solidFill>
-                <a:latin typeface="Be Vietnam Pro" pitchFamily="34" charset="0"/>
-                <a:ea typeface="Be Vietnam Pro" pitchFamily="34" charset="-122"/>
-                <a:cs typeface="Be Vietnam Pro" pitchFamily="34" charset="-120"/>
-              </a:rPr>
-              <a:t> nhanh</a:t>
-            </a:r>
-            <a:r>
-              <a:rPr lang="en-US" sz="2700" dirty="0" spc="-9" kern="0">
                 <a:solidFill>
                   <a:srgbClr val="F3EEE3"/>
                 </a:solidFill>
@@ -11067,26 +11045,15 @@
               <a:buChar char="•"/>
             </a:pPr>
             <a:r>
-              <a:rPr lang="en-US" sz="2550" dirty="0" spc="-2" kern="0">
-                <a:solidFill>
-                  <a:srgbClr val="F3EEE3"/>
-                </a:solidFill>
-                <a:latin typeface="Be Vietnam Pro" pitchFamily="34" charset="0"/>
-                <a:ea typeface="Be Vietnam Pro" pitchFamily="34" charset="-122"/>
-                <a:cs typeface="Be Vietnam Pro" pitchFamily="34" charset="-120"/>
-              </a:rPr>
-              <a:t>Thời</a:t>
-            </a:r>
-            <a:r>
-              <a:rPr lang="en-US" sz="2550" dirty="0" spc="0" kern="0">
-                <a:solidFill>
-                  <a:srgbClr val="F3EEE3"/>
-                </a:solidFill>
-                <a:latin typeface="Be Vietnam Pro" pitchFamily="34" charset="0"/>
-                <a:ea typeface="Be Vietnam Pro" pitchFamily="34" charset="-122"/>
-                <a:cs typeface="Be Vietnam Pro" pitchFamily="34" charset="-120"/>
-              </a:rPr>
-              <a:t> gian phản</a:t>
+              <a:rPr lang="en-US" sz="2550" dirty="0" spc="1" kern="0">
+                <a:solidFill>
+                  <a:srgbClr val="F3EEE3"/>
+                </a:solidFill>
+                <a:latin typeface="Be Vietnam Pro" pitchFamily="34" charset="0"/>
+                <a:ea typeface="Be Vietnam Pro" pitchFamily="34" charset="-122"/>
+                <a:cs typeface="Be Vietnam Pro" pitchFamily="34" charset="-120"/>
+              </a:rPr>
+              <a:t>Phản</a:t>
             </a:r>
             <a:r>
               <a:rPr lang="en-US" sz="2550" dirty="0" spc="-1" kern="0">
@@ -11100,7 +11067,7 @@
               <a:t> hồi nhanh</a:t>
             </a:r>
             <a:r>
-              <a:rPr lang="en-US" sz="2550" dirty="0" spc="-10" kern="0">
+              <a:rPr lang="en-US" sz="2550" dirty="0" spc="-9" kern="0">
                 <a:solidFill>
                   <a:srgbClr val="F3EEE3"/>
                 </a:solidFill>
@@ -11109,6 +11076,50 @@
                 <a:cs typeface="Be Vietnam Pro" pitchFamily="34" charset="-120"/>
               </a:rPr>
               <a:t> nhất</a:t>
+            </a:r>
+            <a:r>
+              <a:rPr lang="en-US" sz="2550" dirty="0" spc="-19" kern="0">
+                <a:solidFill>
+                  <a:srgbClr val="F3EEE3"/>
+                </a:solidFill>
+                <a:latin typeface="Be Vietnam Pro" pitchFamily="34" charset="0"/>
+                <a:ea typeface="Be Vietnam Pro" pitchFamily="34" charset="-122"/>
+                <a:cs typeface="Be Vietnam Pro" pitchFamily="34" charset="-120"/>
+              </a:rPr>
+              <a:t> và</a:t>
+            </a:r>
+            <a:r>
+              <a:rPr lang="en-US" sz="2550" dirty="0" spc="2" kern="0">
+                <a:solidFill>
+                  <a:srgbClr val="F3EEE3"/>
+                </a:solidFill>
+                <a:latin typeface="Be Vietnam Pro" pitchFamily="34" charset="0"/>
+                <a:ea typeface="Be Vietnam Pro" pitchFamily="34" charset="-122"/>
+                <a:cs typeface="Be Vietnam Pro" pitchFamily="34" charset="-120"/>
+              </a:rPr>
+              <a:t> ít</a:t>
+            </a:r>
+            <a:r>
+              <a:rPr lang="en-US" sz="2550" dirty="0" spc="-33" kern="0">
+                <a:solidFill>
+                  <a:srgbClr val="F3EEE3"/>
+                </a:solidFill>
+                <a:latin typeface="Be Vietnam Pro" pitchFamily="34" charset="0"/>
+                <a:ea typeface="Be Vietnam Pro" pitchFamily="34" charset="-122"/>
+                <a:cs typeface="Be Vietnam Pro" pitchFamily="34" charset="-120"/>
+              </a:rPr>
+              <a:t> kết</a:t>
+            </a:r>
+            <a:r>
+              <a:rPr lang="en-US" sz="2550" dirty="0" spc="-1" kern="0">
+                <a:solidFill>
+                  <a:srgbClr val="F3EEE3"/>
+                </a:solidFill>
+                <a:latin typeface="Be Vietnam Pro" pitchFamily="34" charset="0"/>
+                <a:ea typeface="Be Vietnam Pro" pitchFamily="34" charset="-122"/>
+                <a:cs typeface="Be Vietnam Pro" pitchFamily="34" charset="-120"/>
+              </a:rPr>
+              <a:t> nối</a:t>
             </a:r>
             <a:endParaRPr lang="en-US" sz="2550" dirty="0"/>
           </a:p>
@@ -12295,6 +12306,50 @@
               <a:t> hơn:</a:t>
             </a:r>
             <a:r>
+              <a:rPr lang="en-US" sz="1950" dirty="0" spc="-1" kern="0">
+                <a:solidFill>
+                  <a:srgbClr val="C4C8D6"/>
+                </a:solidFill>
+                <a:latin typeface="Be Vietnam Pro" pitchFamily="34" charset="0"/>
+                <a:ea typeface="Be Vietnam Pro" pitchFamily="34" charset="-122"/>
+                <a:cs typeface="Be Vietnam Pro" pitchFamily="34" charset="-120"/>
+              </a:rPr>
+              <a:t> phản hồi</a:t>
+            </a:r>
+            <a:r>
+              <a:rPr lang="en-US" sz="1950" dirty="0" spc="2" kern="0">
+                <a:solidFill>
+                  <a:srgbClr val="C4C8D6"/>
+                </a:solidFill>
+                <a:latin typeface="Be Vietnam Pro" pitchFamily="34" charset="0"/>
+                <a:ea typeface="Be Vietnam Pro" pitchFamily="34" charset="-122"/>
+                <a:cs typeface="Be Vietnam Pro" pitchFamily="34" charset="-120"/>
+              </a:rPr>
+              <a:t> nhanh</a:t>
+            </a:r>
+            <a:r>
+              <a:rPr lang="en-US" sz="1950" dirty="0" spc="1" kern="0">
+                <a:solidFill>
+                  <a:srgbClr val="C4C8D6"/>
+                </a:solidFill>
+                <a:latin typeface="Be Vietnam Pro" pitchFamily="34" charset="0"/>
+                <a:ea typeface="Be Vietnam Pro" pitchFamily="34" charset="-122"/>
+                <a:cs typeface="Be Vietnam Pro" pitchFamily="34" charset="-120"/>
+              </a:rPr>
+              <a:t> hơn;</a:t>
+            </a:r>
+            <a:r>
+              <a:rPr lang="en-US" sz="1950" dirty="0" spc="-20" kern="0">
+                <a:solidFill>
+                  <a:srgbClr val="C4C8D6"/>
+                </a:solidFill>
+                <a:latin typeface="Be Vietnam Pro" pitchFamily="34" charset="0"/>
+                <a:ea typeface="Be Vietnam Pro" pitchFamily="34" charset="-122"/>
+                <a:cs typeface="Be Vietnam Pro" pitchFamily="34" charset="-120"/>
+              </a:rPr>
+              <a:t> xét</a:t>
+            </a:r>
+            <a:r>
               <a:rPr lang="en-US" sz="1950" dirty="0" spc="-2" kern="0">
                 <a:solidFill>
                   <a:srgbClr val="C4C8D6"/>
@@ -12303,10 +12358,10 @@
                 <a:ea typeface="Be Vietnam Pro" pitchFamily="34" charset="-122"/>
                 <a:cs typeface="Be Vietnam Pro" pitchFamily="34" charset="-120"/>
               </a:rPr>
-              <a:t> thời</a:t>
-            </a:r>
-            <a:r>
-              <a:rPr lang="en-US" sz="1950" dirty="0" spc="3" kern="0">
+              <a:t> cả</a:t>
+            </a:r>
+            <a:r>
+              <a:rPr lang="en-US" sz="1950" dirty="0" spc="-7" kern="0">
                 <a:solidFill>
                   <a:srgbClr val="C4C8D6"/>
                 </a:solidFill>
@@ -12314,10 +12369,10 @@
                 <a:ea typeface="Be Vietnam Pro" pitchFamily="34" charset="-122"/>
                 <a:cs typeface="Be Vietnam Pro" pitchFamily="34" charset="-120"/>
               </a:rPr>
-              <a:t> gian</a:t>
-            </a:r>
-            <a:r>
-              <a:rPr lang="en-US" sz="1950" dirty="0" spc="-1" kern="0">
+              <a:t> số</a:t>
+            </a:r>
+            <a:r>
+              <a:rPr lang="en-US" sz="1950" dirty="0" spc="-29" kern="0">
                 <a:solidFill>
                   <a:srgbClr val="C4C8D6"/>
                 </a:solidFill>
@@ -12325,10 +12380,10 @@
                 <a:ea typeface="Be Vietnam Pro" pitchFamily="34" charset="-122"/>
                 <a:cs typeface="Be Vietnam Pro" pitchFamily="34" charset="-120"/>
               </a:rPr>
-              <a:t> phản hồi</a:t>
-            </a:r>
-            <a:r>
-              <a:rPr lang="en-US" sz="1950" dirty="0" spc="2" kern="0">
+              <a:t> kết</a:t>
+            </a:r>
+            <a:r>
+              <a:rPr lang="en-US" sz="1950" dirty="0" spc="0" kern="0">
                 <a:solidFill>
                   <a:srgbClr val="C4C8D6"/>
                 </a:solidFill>
@@ -12336,18 +12391,7 @@
                 <a:ea typeface="Be Vietnam Pro" pitchFamily="34" charset="-122"/>
                 <a:cs typeface="Be Vietnam Pro" pitchFamily="34" charset="-120"/>
               </a:rPr>
-              <a:t> nhanh</a:t>
-            </a:r>
-            <a:r>
-              <a:rPr lang="en-US" sz="1950" dirty="0" spc="1" kern="0">
-                <a:solidFill>
-                  <a:srgbClr val="C4C8D6"/>
-                </a:solidFill>
-                <a:latin typeface="Be Vietnam Pro" pitchFamily="34" charset="0"/>
-                <a:ea typeface="Be Vietnam Pro" pitchFamily="34" charset="-122"/>
-                <a:cs typeface="Be Vietnam Pro" pitchFamily="34" charset="-120"/>
-              </a:rPr>
-              <a:t> hơn</a:t>
+              <a:t> nối</a:t>
             </a:r>
             <a:endParaRPr lang="en-US" sz="1950" dirty="0"/>
           </a:p>

</xml_diff>